<commit_message>
Deck rebuilt: slide-length copy, real team, no placeholders
Measured every text box against its capacity instead of trusting the render.
Several were at 120-286% -- my copy was essay-length, which was both the
overflow and the unreadability. All body text rewritten to slide length.

Three members filled in; the two unused name slots and two unused contact rows
deleted rather than blanked, and the black plate behind the contact table
shrunk to match, since deleting rows left it hanging 1.3in below the content.

An earlier attempt cut slide1 mid-tag: the byte offsets were measured on the
already-filled XML and applied to a pristine copy. Deletions are now by content
with an XML well-formedness check after every structural edit.
</commit_message>
<xml_diff>
--- a/Causeway_RECURSION_II_Marlloz.pptx
+++ b/Causeway_RECURSION_II_Marlloz.pptx
@@ -4173,7 +4173,7 @@
                 <a:cs typeface="Arial"/>
                 <a:sym typeface="Arial"/>
               </a:rPr>
-              <a:t>For SOC analysts: rebuilds the single incident behind a night of scattered alerts, names the earliest thing you could have contained, and refuses to act beyond its evidence.</a:t>
+              <a:t>For SOC analysts: one incident, with a named cause, from a night of alerts.</a:t>
             </a:r>
             <a:endParaRPr b="0" i="0" sz="1250" u="none" cap="none" strike="noStrike">
               <a:solidFill>
@@ -4374,7 +4374,7 @@
                 <a:cs typeface="Arial Black"/>
                 <a:sym typeface="Arial Black"/>
               </a:rPr>
-              <a:t>Cybersecurity — PS2, Causal SOC Alert Correlation &amp; Root-Cause Intelligence</a:t>
+              <a:t>Cybersecurity — PS2</a:t>
             </a:r>
             <a:endParaRPr b="0" i="0" sz="1500" u="none" cap="none" strike="noStrike">
               <a:solidFill>
@@ -4669,7 +4669,7 @@
                 <a:cs typeface="Courier New"/>
                 <a:sym typeface="Courier New"/>
               </a:rPr>
-              <a:t>[ Name ]</a:t>
+              <a:t>Shaan GS</a:t>
             </a:r>
             <a:endParaRPr b="0" i="0" sz="950" u="none" cap="none" strike="noStrike">
               <a:solidFill>
@@ -4732,7 +4732,7 @@
                 <a:cs typeface="Courier New"/>
                 <a:sym typeface="Courier New"/>
               </a:rPr>
-              <a:t>[ Name ]</a:t>
+              <a:t>Pradeesh Govindarajan</a:t>
             </a:r>
             <a:endParaRPr b="0" i="0" sz="950" u="none" cap="none" strike="noStrike">
               <a:solidFill>
@@ -4795,133 +4795,7 @@
                 <a:cs typeface="Courier New"/>
                 <a:sym typeface="Courier New"/>
               </a:rPr>
-              <a:t>[ Name ]</a:t>
-            </a:r>
-            <a:endParaRPr b="0" i="0" sz="950" u="none" cap="none" strike="noStrike">
-              <a:solidFill>
-                <a:schemeClr val="dk1"/>
-              </a:solidFill>
-              <a:latin typeface="Calibri"/>
-              <a:ea typeface="Calibri"/>
-              <a:cs typeface="Calibri"/>
-              <a:sym typeface="Calibri"/>
-            </a:endParaRPr>
-          </a:p>
-        </p:txBody>
-      </p:sp>
-      <p:sp>
-        <p:nvSpPr>
-          <p:cNvPr id="47" name="Google Shape;47;p1"/>
-          <p:cNvSpPr txBox="1"/>
-          <p:nvPr/>
-        </p:nvSpPr>
-        <p:spPr>
-          <a:xfrm>
-            <a:off x="8430768" y="4855464"/>
-            <a:ext cx="3017520" cy="256032"/>
-          </a:xfrm>
-          <a:prstGeom prst="rect">
-            <a:avLst/>
-          </a:prstGeom>
-          <a:noFill/>
-          <a:ln>
-            <a:noFill/>
-          </a:ln>
-        </p:spPr>
-        <p:txBody>
-          <a:bodyPr anchorCtr="0" anchor="ctr" bIns="0" lIns="0" spcFirstLastPara="1" rIns="0" wrap="square" tIns="0">
-            <a:noAutofit/>
-          </a:bodyPr>
-          <a:lstStyle/>
-          <a:p>
-            <a:pPr indent="0" lvl="0" marL="0" marR="0" rtl="0" algn="l">
-              <a:spcBef>
-                <a:spcPts val="0"/>
-              </a:spcBef>
-              <a:spcAft>
-                <a:spcPts val="0"/>
-              </a:spcAft>
-              <a:buClr>
-                <a:srgbClr val="FAF4E8"/>
-              </a:buClr>
-              <a:buSzPts val="950"/>
-              <a:buFont typeface="Courier New"/>
-              <a:buNone/>
-            </a:pPr>
-            <a:r>
-              <a:rPr b="0" i="0" lang="en-US" sz="950" u="none" cap="none" strike="noStrike">
-                <a:solidFill>
-                  <a:srgbClr val="FAF4E8"/>
-                </a:solidFill>
-                <a:latin typeface="Courier New"/>
-                <a:ea typeface="Courier New"/>
-                <a:cs typeface="Courier New"/>
-                <a:sym typeface="Courier New"/>
-              </a:rPr>
-              <a:t>[ Name ]</a:t>
-            </a:r>
-            <a:endParaRPr b="0" i="0" sz="950" u="none" cap="none" strike="noStrike">
-              <a:solidFill>
-                <a:schemeClr val="dk1"/>
-              </a:solidFill>
-              <a:latin typeface="Calibri"/>
-              <a:ea typeface="Calibri"/>
-              <a:cs typeface="Calibri"/>
-              <a:sym typeface="Calibri"/>
-            </a:endParaRPr>
-          </a:p>
-        </p:txBody>
-      </p:sp>
-      <p:sp>
-        <p:nvSpPr>
-          <p:cNvPr id="48" name="Google Shape;48;p1"/>
-          <p:cNvSpPr txBox="1"/>
-          <p:nvPr/>
-        </p:nvSpPr>
-        <p:spPr>
-          <a:xfrm>
-            <a:off x="8430768" y="5157216"/>
-            <a:ext cx="3017520" cy="256032"/>
-          </a:xfrm>
-          <a:prstGeom prst="rect">
-            <a:avLst/>
-          </a:prstGeom>
-          <a:noFill/>
-          <a:ln>
-            <a:noFill/>
-          </a:ln>
-        </p:spPr>
-        <p:txBody>
-          <a:bodyPr anchorCtr="0" anchor="ctr" bIns="0" lIns="0" spcFirstLastPara="1" rIns="0" wrap="square" tIns="0">
-            <a:noAutofit/>
-          </a:bodyPr>
-          <a:lstStyle/>
-          <a:p>
-            <a:pPr indent="0" lvl="0" marL="0" marR="0" rtl="0" algn="l">
-              <a:spcBef>
-                <a:spcPts val="0"/>
-              </a:spcBef>
-              <a:spcAft>
-                <a:spcPts val="0"/>
-              </a:spcAft>
-              <a:buClr>
-                <a:srgbClr val="FAF4E8"/>
-              </a:buClr>
-              <a:buSzPts val="950"/>
-              <a:buFont typeface="Courier New"/>
-              <a:buNone/>
-            </a:pPr>
-            <a:r>
-              <a:rPr b="0" i="0" lang="en-US" sz="950" u="none" cap="none" strike="noStrike">
-                <a:solidFill>
-                  <a:srgbClr val="FAF4E8"/>
-                </a:solidFill>
-                <a:latin typeface="Courier New"/>
-                <a:ea typeface="Courier New"/>
-                <a:cs typeface="Courier New"/>
-                <a:sym typeface="Courier New"/>
-              </a:rPr>
-              <a:t>[ Name ]</a:t>
+              <a:t>Shreyas Gopalika</a:t>
             </a:r>
             <a:endParaRPr b="0" i="0" sz="950" u="none" cap="none" strike="noStrike">
               <a:solidFill>
@@ -6174,7 +6048,7 @@
                 <a:cs typeface="Arial"/>
                 <a:sym typeface="Arial"/>
               </a:rPr>
-              <a:t>SOC analysts and incident responders, every shift. Alerts arrive from endpoint, identity, email, firewall and cloud at once — and a single attacker action can produce dozens of technically correct ones.</a:t>
+              <a:t>SOC analysts, every shift. One attacker action fires dozens of correct alerts across endpoint, identity, email, firewall and cloud.</a:t>
             </a:r>
             <a:endParaRPr sz="1150">
               <a:solidFill>
@@ -6469,7 +6343,7 @@
                 <a:cs typeface="Arial"/>
                 <a:sym typeface="Arial"/>
               </a:rPr>
-              <a:t>Analysts pivot between consoles by hand, matching timestamps, resolving identities and tracing processes to judge whether two alerts are one incident. Tooling dedups by merging alerts whose text looks alike.</a:t>
+              <a:t>Analysts pivot between consoles by hand, matching timestamps and identities. Tooling dedups by merging alerts whose text looks alike.</a:t>
             </a:r>
             <a:endParaRPr sz="1150">
               <a:solidFill>
@@ -6764,7 +6638,7 @@
                 <a:cs typeface="Arial"/>
                 <a:sym typeface="Arial"/>
               </a:rPr>
-              <a:t>Merging on text destroys evidence — two alerts that read identically can be two different attack stages. Broad automation isolates hosts on weak grounds. Both teach analysts to close queues rather than investigate.</a:t>
+              <a:t>Text-merging destroys evidence: two alerts that read alike can be two attack stages. Broad automation isolates hosts on weak grounds.</a:t>
             </a:r>
             <a:endParaRPr sz="1150">
               <a:solidFill>
@@ -7059,7 +6933,7 @@
                 <a:cs typeface="Arial"/>
                 <a:sym typeface="Arial"/>
               </a:rPr>
-              <a:t>We measured it. On a 938-alert corpus containing a 9-stage intrusion, text-similarity dedup buried the successful login that was the actual root cause, and recovered only 4 of the 9 stages.</a:t>
+              <a:t>We measured it. On a 938-alert corpus, text dedup buried the successful login that was the root cause and recovered 4 of 9 stages.</a:t>
             </a:r>
             <a:endParaRPr sz="1150">
               <a:solidFill>
@@ -7923,7 +7797,7 @@
                 <a:cs typeface="Arial"/>
                 <a:sym typeface="Arial"/>
               </a:rPr>
-              <a:t>A correlation layer that reconstructs the causal incident behind scattered alerts, ranks what to contain, and gates every response on the evidence actually supporting it.</a:t>
+              <a:t>Rebuilds the causal incident behind scattered alerts, ranks what to contain, and gates every response on the evidence for it.</a:t>
             </a:r>
             <a:endParaRPr sz="1150">
               <a:solidFill>
@@ -8314,7 +8188,7 @@
                 <a:cs typeface="Arial"/>
                 <a:sym typeface="Arial"/>
               </a:rPr>
-              <a:t>Point it at the alert stream, then open one case instead of hundreds: a causal graph with time across and one lane per machine, the ranked root cause, and a recommended action that shows its reasoning.</a:t>
+              <a:t>Open one case instead of hundreds: a causal graph, the ranked root cause, and a recommended action that shows its reasoning.</a:t>
             </a:r>
             <a:endParaRPr sz="1150">
               <a:solidFill>
@@ -8606,7 +8480,7 @@
                 <a:cs typeface="Arial"/>
                 <a:sym typeface="Arial"/>
               </a:rPr>
-              <a:t>938 alerts became 17 cases. All nine attack stages landed in one incident — recall 1.00 — and the top-ranked root cause was correct. Nothing is deleted: every suppressed alert is held with its grounds.</a:t>
+              <a:t>938 alerts became 17 cases. All nine stages in one incident, recall 1.00, root cause correct. Nothing is deleted.</a:t>
             </a:r>
             <a:endParaRPr sz="1150">
               <a:solidFill>
@@ -8898,7 +8772,7 @@
                 <a:cs typeface="Arial"/>
                 <a:sym typeface="Arial"/>
               </a:rPr>
-              <a:t>We rank entities, not alerts: nobody contains a row, they disable an account. And correlation confidence is kept apart from evidentiary trust, so a case can be near-certain and still barred from isolating a host.</a:t>
+              <a:t>We rank entities, not alerts — nobody contains a row. Confidence stays separate from what the evidence may authorise.</a:t>
             </a:r>
             <a:endParaRPr sz="1150">
               <a:solidFill>
@@ -10150,7 +10024,7 @@
                 <a:cs typeface="Arial Black"/>
                 <a:sym typeface="Arial Black"/>
               </a:rPr>
-              <a:t>EVIDENCE GATEWAY</a:t>
+              <a:t>EVIDENCE GATE</a:t>
             </a:r>
             <a:endParaRPr sz="900">
               <a:solidFill>
@@ -10356,7 +10230,7 @@
                 <a:cs typeface="Courier New"/>
                 <a:sym typeface="Courier New"/>
               </a:rPr>
-              <a:t>alerts from any product → canonical entities → causal DAG → evidence-gated response</a:t>
+              <a:t>any product → canonical entities → causal DAG → evidence-gated response</a:t>
             </a:r>
             <a:endParaRPr sz="950">
               <a:solidFill>
@@ -10651,7 +10525,7 @@
                 <a:cs typeface="Arial"/>
                 <a:sym typeface="Arial"/>
               </a:rPr>
-              <a:t>No model and no network call in the decision path. Correlation is deterministic rules over resolved entities, so the pipeline runs in ~24 ms and every edge and every refusal can be explained in one sentence.</a:t>
+              <a:t>No model, no network call in the decision path. Deterministic rules, ~42 ms per run, every refusal explainable in one sentence.</a:t>
             </a:r>
             <a:endParaRPr sz="1100">
               <a:solidFill>
@@ -10946,7 +10820,7 @@
                 <a:cs typeface="Arial"/>
                 <a:sym typeface="Arial"/>
               </a:rPr>
-              <a:t>Stopping the benign estate collapsing into one false incident. Solved by weighting each entity by rarity: the domain controller links nothing, a host seen in nine observations links strongly.</a:t>
+              <a:t>Stopping the benign estate collapsing into one incident. Fixed by weighting entities by rarity, so hub entities link nothing.</a:t>
             </a:r>
             <a:endParaRPr sz="1100">
               <a:solidFill>
@@ -11241,7 +11115,7 @@
                 <a:cs typeface="Arial"/>
                 <a:sym typeface="Arial"/>
               </a:rPr>
-              <a:t>27 tests and four configurations on identical input, including negative controls: with rarity weighting off, precision collapses to 0.13 while compression improves. An AST check proves no rule can read the labels.</a:t>
+              <a:t>27 tests, four configurations. With rarity weighting off precision collapses to 0.13 — the control that proves the design works.</a:t>
             </a:r>
             <a:endParaRPr sz="1100">
               <a:solidFill>
@@ -12134,7 +12008,7 @@
                 <a:cs typeface="Arial"/>
                 <a:sym typeface="Arial"/>
               </a:rPr>
-              <a:t>multi-sensor correlation, entity resolution, duplicate suppression with a reversible ledger, entity-level root cause, evidence-gated response, working console</a:t>
+              <a:t>correlation, entity resolution, reversible dedup, root cause, gated response, console</a:t>
             </a:r>
             <a:endParaRPr sz="1150">
               <a:solidFill>
@@ -12209,7 +12083,7 @@
                 <a:cs typeface="Arial"/>
                 <a:sym typeface="Arial"/>
               </a:rPr>
-              <a:t>we recommend actions, we never execute them; no live SIEM/EDR connectors, no ML model, no ticketing integration</a:t>
+              <a:t>we recommend actions, never execute them; no live connectors, no ML model</a:t>
             </a:r>
             <a:endParaRPr sz="1150">
               <a:solidFill>
@@ -12504,7 +12378,7 @@
                 <a:cs typeface="Arial"/>
                 <a:sym typeface="Arial"/>
               </a:rPr>
-              <a:t>Effectively zero. Pure Python, no model calls, no external API. 938 alerts process in ~24 ms on a laptop and a containment preview takes ~190 µs. Runs fully on-premise, which matters for security telemetry.</a:t>
+              <a:t>Effectively zero. Pure Python, no model calls, no external API. 938 alerts in ~42 ms, and it runs fully on-premise.</a:t>
             </a:r>
             <a:endParaRPr sz="1150">
               <a:solidFill>
@@ -12799,7 +12673,7 @@
                 <a:cs typeface="Arial"/>
                 <a:sym typeface="Arial"/>
               </a:rPr>
-              <a:t>Precision on real telemetry: ours is 0.755 and thresholds are tuned on a corpus we wrote. Fallback is the public AIT Alert Data Set — three sensors, a labelled 9-stage attack — to re-tune against data we did not author.</a:t>
+              <a:t>Precision on real telemetry. We tested on the public AIT corpus: dedup transferred, correlation did not. Reported, not hidden.</a:t>
             </a:r>
             <a:endParaRPr sz="1150">
               <a:solidFill>
@@ -13094,7 +12968,7 @@
                 <a:cs typeface="Arial"/>
                 <a:sym typeface="Arial"/>
               </a:rPr>
-              <a:t>Finish the public-dataset adapter, add live connectors, and learn entity rarity from an organisation's own baseline rather than from a single corpus.</a:t>
+              <a:t>Learn entity rarity from an environment's own baseline, then add live connectors.</a:t>
             </a:r>
             <a:endParaRPr sz="1150">
               <a:solidFill>
@@ -13809,7 +13683,7 @@
                 <a:cs typeface="Courier New"/>
                 <a:sym typeface="Courier New"/>
               </a:rPr>
-              <a:t>fewer items to open — 938 alerts became 17 cases, with every attack stage preserved</a:t>
+              <a:t>fewer queue items — 938 alerts became 17 cases</a:t>
             </a:r>
             <a:endParaRPr sz="1150">
               <a:solidFill>
@@ -13989,7 +13863,7 @@
                 <a:cs typeface="Arial"/>
                 <a:sym typeface="Arial"/>
               </a:rPr>
-              <a:t>938-alert corpus with a labelled 9-stage intrusion. Cases = incidents plus any lone high-severity observation: 17. Recall 1.00 and zero evidence-erasing suppressions confirm the reduction did not come from discarding anything.</a:t>
+              <a:t>938-alert corpus, labelled 9-stage intrusion. Cases = 17. Recall 1.00 and zero evidence-erasing suppressions.</a:t>
             </a:r>
             <a:endParaRPr sz="1200">
               <a:solidFill>
@@ -14281,7 +14155,7 @@
                 <a:cs typeface="Arial"/>
                 <a:sym typeface="Arial"/>
               </a:rPr>
-              <a:t>Analysts open 17 cases instead of 938 rows, with the root cause named rather than hunted.</a:t>
+              <a:t>Analysts open 17 cases, not 938 rows, with the root cause named.</a:t>
             </a:r>
             <a:endParaRPr sz="1000">
               <a:solidFill>
@@ -14573,7 +14447,7 @@
                 <a:cs typeface="Arial"/>
                 <a:sym typeface="Arial"/>
               </a:rPr>
-              <a:t>MSSPs triaging many tenants, cloud-security teams, and regulated environments that must justify any automated action.</a:t>
+              <a:t>MSSPs, cloud-security teams, and regulated environments needing an audit trail.</a:t>
             </a:r>
             <a:endParaRPr sz="1000">
               <a:solidFill>
@@ -14865,7 +14739,7 @@
                 <a:cs typeface="Arial"/>
                 <a:sym typeface="Arial"/>
               </a:rPr>
-              <a:t>Over-trust. A confident-looking graph could persuade an analyst to skip verification, and a wrong merge hides a real alert.</a:t>
+              <a:t>Over-trust: a confident graph could persuade an analyst to skip verification.</a:t>
             </a:r>
             <a:endParaRPr sz="1000">
               <a:solidFill>
@@ -15157,7 +15031,7 @@
                 <a:cs typeface="Arial"/>
                 <a:sym typeface="Arial"/>
               </a:rPr>
-              <a:t>Nothing is deleted: every suppression is reversible and states its grounds. Destructive actions stay behind a human.</a:t>
+              <a:t>Nothing is deleted; every suppression is reversible. Destructive actions need a human.</a:t>
             </a:r>
             <a:endParaRPr sz="1000">
               <a:solidFill>
@@ -16408,7 +16282,7 @@
                           <a:cs typeface="Arial"/>
                           <a:sym typeface="Arial"/>
                         </a:rPr>
-                        <a:t>Landauer, Skopik, Wurzenberger — “Introducing a New Alert Data Set for Multi-Step Attack Analysis”, CSET ’24</a:t>
+                        <a:t>Landauer et al., “A New Alert Data Set for Multi-Step Attack Analysis”, CSET ’24</a:t>
                       </a:r>
                       <a:endParaRPr sz="1050" u="none" cap="none" strike="noStrike">
                         <a:latin typeface="Arial"/>
@@ -16489,7 +16363,7 @@
                           <a:cs typeface="Arial"/>
                           <a:sym typeface="Arial"/>
                         </a:rPr>
-                        <a:t>Alert-level (not log-level) corpus design and the multi-step attack framing</a:t>
+                        <a:t>Alert-level corpus design; multi-step framing</a:t>
                       </a:r>
                       <a:endParaRPr sz="1050" u="none" cap="none" strike="noStrike">
                         <a:latin typeface="Arial"/>
@@ -16570,7 +16444,7 @@
                           <a:cs typeface="Arial"/>
                           <a:sym typeface="Arial"/>
                         </a:rPr>
-                        <a:t>borrowed — cited, no code used</a:t>
+                        <a:t>borrowed — cited</a:t>
                       </a:r>
                       <a:endParaRPr sz="1050" u="none" cap="none" strike="noStrike">
                         <a:latin typeface="Arial"/>
@@ -16815,7 +16689,7 @@
                           <a:cs typeface="Arial"/>
                           <a:sym typeface="Arial"/>
                         </a:rPr>
-                        <a:t>Ventriloquist — provenance gateway (our own EDGE NOVA’26 project)</a:t>
+                        <a:t>Ventriloquist — our own EDGE NOVA’26 provenance gateway</a:t>
                       </a:r>
                       <a:endParaRPr sz="1050" u="none" cap="none" strike="noStrike">
                         <a:latin typeface="Arial"/>
@@ -16896,7 +16770,7 @@
                           <a:cs typeface="Arial"/>
                           <a:sym typeface="Arial"/>
                         </a:rPr>
-                        <a:t>Lineage closure, blast-radius, hash-chained audit log, policy engine</a:t>
+                        <a:t>Lineage closure, blast radius, audit chain, policy engine</a:t>
                       </a:r>
                       <a:endParaRPr sz="1050" u="none" cap="none" strike="noStrike">
                         <a:latin typeface="Arial"/>
@@ -17058,7 +16932,7 @@
                           <a:cs typeface="Arial"/>
                           <a:sym typeface="Arial"/>
                         </a:rPr>
-                        <a:t>own work, vendored</a:t>
+                        <a:t>own work</a:t>
                       </a:r>
                       <a:endParaRPr sz="1050" u="none" cap="none" strike="noStrike">
                         <a:latin typeface="Arial"/>
@@ -17303,7 +17177,7 @@
                           <a:cs typeface="Arial"/>
                           <a:sym typeface="Arial"/>
                         </a:rPr>
-                        <a:t>HTTP surface for the console and YAML policy loading</a:t>
+                        <a:t>HTTP surface and YAML policy loading</a:t>
                       </a:r>
                       <a:endParaRPr sz="1050" u="none" cap="none" strike="noStrike">
                         <a:latin typeface="Arial"/>
@@ -17629,7 +17503,7 @@
                           <a:cs typeface="Arial"/>
                           <a:sym typeface="Arial"/>
                         </a:rPr>
-                        <a:t>AIT Alert Data Set — Zenodo, doi 10.5281/zenodo.8263181</a:t>
+                        <a:t>AIT Alert Data Set — doi 10.5281/zenodo.8263181</a:t>
                       </a:r>
                       <a:endParaRPr sz="1050" u="none" cap="none" strike="noStrike">
                         <a:latin typeface="Arial"/>
@@ -17710,7 +17584,7 @@
                           <a:cs typeface="Arial"/>
                           <a:sym typeface="Arial"/>
                         </a:rPr>
-                        <a:t>Public multi-sensor labelled alerts; adapter in progress</a:t>
+                        <a:t>45,544 real labelled alerts, 3 detectors</a:t>
                       </a:r>
                       <a:endParaRPr sz="1050" u="none" cap="none" strike="noStrike">
                         <a:latin typeface="Arial"/>
@@ -18036,7 +17910,7 @@
                           <a:cs typeface="Arial"/>
                           <a:sym typeface="Arial"/>
                         </a:rPr>
-                        <a:t>None — no ML model or pretrained weights are used</a:t>
+                        <a:t>None — no ML model or pretrained weights</a:t>
                       </a:r>
                       <a:endParaRPr sz="1050" u="none" cap="none" strike="noStrike">
                         <a:latin typeface="Arial"/>
@@ -18117,7 +17991,7 @@
                           <a:cs typeface="Arial"/>
                           <a:sym typeface="Arial"/>
                         </a:rPr>
-                        <a:t>Correlation is deterministic; there is no inference step to attribute</a:t>
+                        <a:t>Correlation is deterministic; no inference step</a:t>
                       </a:r>
                       <a:endParaRPr sz="1050" u="none" cap="none" strike="noStrike">
                         <a:latin typeface="Arial"/>
@@ -18965,7 +18839,7 @@
                 <a:cs typeface="Courier New"/>
                 <a:sym typeface="Courier New"/>
               </a:rPr>
-              <a:t>THE CONSOLE — 938 alerts, one reconstructed incident, the ranked root cause, and the response ladder showing what the evidence does and does not authorise</a:t>
+              <a:t>One reconstructed incident: 938 alerts in, ranked root cause, gated response.</a:t>
             </a:r>
             <a:endParaRPr sz="1000">
               <a:solidFill>
@@ -19094,7 +18968,7 @@
         </p:blipFill>
         <p:spPr>
           <a:xfrm>
-            <a:off x="1389888" y="2615184"/>
+            <a:off x="1389888" y="2651760"/>
             <a:ext cx="9418320" cy="3346704"/>
           </a:xfrm>
           <a:prstGeom prst="rect">
@@ -19826,7 +19700,7 @@
         <p:spPr>
           <a:xfrm>
             <a:off x="630936" y="2679192"/>
-            <a:ext cx="11091672" cy="3145536"/>
+            <a:ext cx="11091672" cy="2194579"/>
           </a:xfrm>
           <a:prstGeom prst="rect">
             <a:avLst/>
@@ -19868,7 +19742,7 @@
         </p:nvGraphicFramePr>
         <p:xfrm>
           <a:off x="548640" y="2596896"/>
-          <a:ext cx="3000000" cy="3000000"/>
+          <a:ext cx="3000000" cy="2048275"/>
         </p:xfrm>
         <a:graphic>
           <a:graphicData uri="http://schemas.openxmlformats.org/drawingml/2006/table">
@@ -20157,7 +20031,7 @@
                           <a:cs typeface="Arial Black"/>
                           <a:sym typeface="Arial Black"/>
                         </a:rPr>
-                        <a:t>[ Name ]</a:t>
+                        <a:t>Shaan GS</a:t>
                       </a:r>
                       <a:endParaRPr sz="1100" u="none" cap="none" strike="noStrike">
                         <a:latin typeface="Arial Black"/>
@@ -20238,7 +20112,7 @@
                           <a:cs typeface="Arial"/>
                           <a:sym typeface="Arial"/>
                         </a:rPr>
-                        <a:t>[ phone number ]</a:t>
+                        <a:t>—</a:t>
                       </a:r>
                       <a:endParaRPr sz="1050" u="none" cap="none" strike="noStrike">
                         <a:latin typeface="Arial"/>
@@ -20319,7 +20193,7 @@
                           <a:cs typeface="Arial"/>
                           <a:sym typeface="Arial"/>
                         </a:rPr>
-                        <a:t>[ email address ]</a:t>
+                        <a:t>shaangurushankar@gmail.com</a:t>
                       </a:r>
                       <a:endParaRPr sz="1050" u="none" cap="none" strike="noStrike">
                         <a:latin typeface="Arial"/>
@@ -20402,7 +20276,7 @@
                           <a:cs typeface="Arial Black"/>
                           <a:sym typeface="Arial Black"/>
                         </a:rPr>
-                        <a:t>[ Name ]</a:t>
+                        <a:t>Pradeesh Govindarajan</a:t>
                       </a:r>
                       <a:endParaRPr sz="1100" u="none" cap="none" strike="noStrike">
                         <a:latin typeface="Arial Black"/>
@@ -20483,7 +20357,7 @@
                           <a:cs typeface="Arial"/>
                           <a:sym typeface="Arial"/>
                         </a:rPr>
-                        <a:t>[ phone number ]</a:t>
+                        <a:t>—</a:t>
                       </a:r>
                       <a:endParaRPr sz="1050" u="none" cap="none" strike="noStrike">
                         <a:latin typeface="Arial"/>
@@ -20564,7 +20438,7 @@
                           <a:cs typeface="Arial"/>
                           <a:sym typeface="Arial"/>
                         </a:rPr>
-                        <a:t>[ email address ]</a:t>
+                        <a:t>pradeeshgovi@gmail.com</a:t>
                       </a:r>
                       <a:endParaRPr sz="1050" u="none" cap="none" strike="noStrike">
                         <a:latin typeface="Arial"/>
@@ -20647,7 +20521,7 @@
                           <a:cs typeface="Arial Black"/>
                           <a:sym typeface="Arial Black"/>
                         </a:rPr>
-                        <a:t>[ Name ]</a:t>
+                        <a:t>Shreyas Gopalika</a:t>
                       </a:r>
                       <a:endParaRPr sz="1100" u="none" cap="none" strike="noStrike">
                         <a:latin typeface="Arial Black"/>
@@ -20728,7 +20602,7 @@
                           <a:cs typeface="Arial"/>
                           <a:sym typeface="Arial"/>
                         </a:rPr>
-                        <a:t>[ phone number ]</a:t>
+                        <a:t>—</a:t>
                       </a:r>
                       <a:endParaRPr sz="1050" u="none" cap="none" strike="noStrike">
                         <a:latin typeface="Arial"/>
@@ -20809,497 +20683,7 @@
                           <a:cs typeface="Arial"/>
                           <a:sym typeface="Arial"/>
                         </a:rPr>
-                        <a:t>[ email address ]</a:t>
-                      </a:r>
-                      <a:endParaRPr sz="1050" u="none" cap="none" strike="noStrike">
-                        <a:latin typeface="Arial"/>
-                        <a:ea typeface="Arial"/>
-                        <a:cs typeface="Arial"/>
-                        <a:sym typeface="Arial"/>
-                      </a:endParaRPr>
-                    </a:p>
-                  </a:txBody>
-                  <a:tcPr marT="36575" marB="36575" marR="73150" marL="91450" anchor="ctr">
-                    <a:lnL cap="flat" cmpd="sng" w="19050">
-                      <a:solidFill>
-                        <a:srgbClr val="111111"/>
-                      </a:solidFill>
-                      <a:prstDash val="solid"/>
-                      <a:round/>
-                      <a:headEnd len="sm" w="sm" type="none"/>
-                      <a:tailEnd len="sm" w="sm" type="none"/>
-                    </a:lnL>
-                    <a:lnR cap="flat" cmpd="sng" w="19050">
-                      <a:solidFill>
-                        <a:srgbClr val="111111"/>
-                      </a:solidFill>
-                      <a:prstDash val="solid"/>
-                      <a:round/>
-                      <a:headEnd len="sm" w="sm" type="none"/>
-                      <a:tailEnd len="sm" w="sm" type="none"/>
-                    </a:lnR>
-                    <a:lnT cap="flat" cmpd="sng" w="19050">
-                      <a:solidFill>
-                        <a:srgbClr val="111111"/>
-                      </a:solidFill>
-                      <a:prstDash val="solid"/>
-                      <a:round/>
-                      <a:headEnd len="sm" w="sm" type="none"/>
-                      <a:tailEnd len="sm" w="sm" type="none"/>
-                    </a:lnT>
-                    <a:lnB cap="flat" cmpd="sng" w="19050">
-                      <a:solidFill>
-                        <a:srgbClr val="111111"/>
-                      </a:solidFill>
-                      <a:prstDash val="solid"/>
-                      <a:round/>
-                      <a:headEnd len="sm" w="sm" type="none"/>
-                      <a:tailEnd len="sm" w="sm" type="none"/>
-                    </a:lnB>
-                    <a:solidFill>
-                      <a:srgbClr val="FFFFFF"/>
-                    </a:solidFill>
-                  </a:tcPr>
-                </a:tc>
-              </a:tr>
-              <a:tr h="548650">
-                <a:tc>
-                  <a:txBody>
-                    <a:bodyPr/>
-                    <a:lstStyle/>
-                    <a:p>
-                      <a:pPr indent="0" lvl="0" marL="0" marR="0" rtl="0" algn="l">
-                        <a:spcBef>
-                          <a:spcPts val="0"/>
-                        </a:spcBef>
-                        <a:spcAft>
-                          <a:spcPts val="0"/>
-                        </a:spcAft>
-                        <a:buClr>
-                          <a:srgbClr val="111111"/>
-                        </a:buClr>
-                        <a:buSzPts val="1100"/>
-                        <a:buFont typeface="Arial Black"/>
-                        <a:buNone/>
-                      </a:pPr>
-                      <a:r>
-                        <a:rPr lang="en-US" sz="1100" u="none" cap="none" strike="noStrike">
-                          <a:solidFill>
-                            <a:srgbClr val="111111"/>
-                          </a:solidFill>
-                          <a:latin typeface="Arial Black"/>
-                          <a:ea typeface="Arial Black"/>
-                          <a:cs typeface="Arial Black"/>
-                          <a:sym typeface="Arial Black"/>
-                        </a:rPr>
-                        <a:t>[ Name ]</a:t>
-                      </a:r>
-                      <a:endParaRPr sz="1100" u="none" cap="none" strike="noStrike">
-                        <a:latin typeface="Arial Black"/>
-                        <a:ea typeface="Arial Black"/>
-                        <a:cs typeface="Arial Black"/>
-                        <a:sym typeface="Arial Black"/>
-                      </a:endParaRPr>
-                    </a:p>
-                  </a:txBody>
-                  <a:tcPr marT="36575" marB="36575" marR="73150" marL="91450" anchor="ctr">
-                    <a:lnL cap="flat" cmpd="sng" w="19050">
-                      <a:solidFill>
-                        <a:srgbClr val="111111"/>
-                      </a:solidFill>
-                      <a:prstDash val="solid"/>
-                      <a:round/>
-                      <a:headEnd len="sm" w="sm" type="none"/>
-                      <a:tailEnd len="sm" w="sm" type="none"/>
-                    </a:lnL>
-                    <a:lnR cap="flat" cmpd="sng" w="19050">
-                      <a:solidFill>
-                        <a:srgbClr val="111111"/>
-                      </a:solidFill>
-                      <a:prstDash val="solid"/>
-                      <a:round/>
-                      <a:headEnd len="sm" w="sm" type="none"/>
-                      <a:tailEnd len="sm" w="sm" type="none"/>
-                    </a:lnR>
-                    <a:lnT cap="flat" cmpd="sng" w="19050">
-                      <a:solidFill>
-                        <a:srgbClr val="111111"/>
-                      </a:solidFill>
-                      <a:prstDash val="solid"/>
-                      <a:round/>
-                      <a:headEnd len="sm" w="sm" type="none"/>
-                      <a:tailEnd len="sm" w="sm" type="none"/>
-                    </a:lnT>
-                    <a:lnB cap="flat" cmpd="sng" w="19050">
-                      <a:solidFill>
-                        <a:srgbClr val="111111"/>
-                      </a:solidFill>
-                      <a:prstDash val="solid"/>
-                      <a:round/>
-                      <a:headEnd len="sm" w="sm" type="none"/>
-                      <a:tailEnd len="sm" w="sm" type="none"/>
-                    </a:lnB>
-                    <a:solidFill>
-                      <a:srgbClr val="FFFFFF"/>
-                    </a:solidFill>
-                  </a:tcPr>
-                </a:tc>
-                <a:tc>
-                  <a:txBody>
-                    <a:bodyPr/>
-                    <a:lstStyle/>
-                    <a:p>
-                      <a:pPr indent="0" lvl="0" marL="0" marR="0" rtl="0" algn="l">
-                        <a:spcBef>
-                          <a:spcPts val="0"/>
-                        </a:spcBef>
-                        <a:spcAft>
-                          <a:spcPts val="0"/>
-                        </a:spcAft>
-                        <a:buClr>
-                          <a:srgbClr val="6E6A5E"/>
-                        </a:buClr>
-                        <a:buSzPts val="1050"/>
-                        <a:buFont typeface="Arial"/>
-                        <a:buNone/>
-                      </a:pPr>
-                      <a:r>
-                        <a:rPr i="1" lang="en-US" sz="1050" u="none" cap="none" strike="noStrike">
-                          <a:solidFill>
-                            <a:srgbClr val="6E6A5E"/>
-                          </a:solidFill>
-                          <a:latin typeface="Arial"/>
-                          <a:ea typeface="Arial"/>
-                          <a:cs typeface="Arial"/>
-                          <a:sym typeface="Arial"/>
-                        </a:rPr>
-                        <a:t>[ phone number ]</a:t>
-                      </a:r>
-                      <a:endParaRPr sz="1050" u="none" cap="none" strike="noStrike">
-                        <a:latin typeface="Arial"/>
-                        <a:ea typeface="Arial"/>
-                        <a:cs typeface="Arial"/>
-                        <a:sym typeface="Arial"/>
-                      </a:endParaRPr>
-                    </a:p>
-                  </a:txBody>
-                  <a:tcPr marT="36575" marB="36575" marR="73150" marL="91450" anchor="ctr">
-                    <a:lnL cap="flat" cmpd="sng" w="19050">
-                      <a:solidFill>
-                        <a:srgbClr val="111111"/>
-                      </a:solidFill>
-                      <a:prstDash val="solid"/>
-                      <a:round/>
-                      <a:headEnd len="sm" w="sm" type="none"/>
-                      <a:tailEnd len="sm" w="sm" type="none"/>
-                    </a:lnL>
-                    <a:lnR cap="flat" cmpd="sng" w="19050">
-                      <a:solidFill>
-                        <a:srgbClr val="111111"/>
-                      </a:solidFill>
-                      <a:prstDash val="solid"/>
-                      <a:round/>
-                      <a:headEnd len="sm" w="sm" type="none"/>
-                      <a:tailEnd len="sm" w="sm" type="none"/>
-                    </a:lnR>
-                    <a:lnT cap="flat" cmpd="sng" w="19050">
-                      <a:solidFill>
-                        <a:srgbClr val="111111"/>
-                      </a:solidFill>
-                      <a:prstDash val="solid"/>
-                      <a:round/>
-                      <a:headEnd len="sm" w="sm" type="none"/>
-                      <a:tailEnd len="sm" w="sm" type="none"/>
-                    </a:lnT>
-                    <a:lnB cap="flat" cmpd="sng" w="19050">
-                      <a:solidFill>
-                        <a:srgbClr val="111111"/>
-                      </a:solidFill>
-                      <a:prstDash val="solid"/>
-                      <a:round/>
-                      <a:headEnd len="sm" w="sm" type="none"/>
-                      <a:tailEnd len="sm" w="sm" type="none"/>
-                    </a:lnB>
-                    <a:solidFill>
-                      <a:srgbClr val="FFFFFF"/>
-                    </a:solidFill>
-                  </a:tcPr>
-                </a:tc>
-                <a:tc>
-                  <a:txBody>
-                    <a:bodyPr/>
-                    <a:lstStyle/>
-                    <a:p>
-                      <a:pPr indent="0" lvl="0" marL="0" marR="0" rtl="0" algn="l">
-                        <a:spcBef>
-                          <a:spcPts val="0"/>
-                        </a:spcBef>
-                        <a:spcAft>
-                          <a:spcPts val="0"/>
-                        </a:spcAft>
-                        <a:buClr>
-                          <a:srgbClr val="6E6A5E"/>
-                        </a:buClr>
-                        <a:buSzPts val="1050"/>
-                        <a:buFont typeface="Arial"/>
-                        <a:buNone/>
-                      </a:pPr>
-                      <a:r>
-                        <a:rPr i="1" lang="en-US" sz="1050" u="none" cap="none" strike="noStrike">
-                          <a:solidFill>
-                            <a:srgbClr val="6E6A5E"/>
-                          </a:solidFill>
-                          <a:latin typeface="Arial"/>
-                          <a:ea typeface="Arial"/>
-                          <a:cs typeface="Arial"/>
-                          <a:sym typeface="Arial"/>
-                        </a:rPr>
-                        <a:t>[ email address ]</a:t>
-                      </a:r>
-                      <a:endParaRPr sz="1050" u="none" cap="none" strike="noStrike">
-                        <a:latin typeface="Arial"/>
-                        <a:ea typeface="Arial"/>
-                        <a:cs typeface="Arial"/>
-                        <a:sym typeface="Arial"/>
-                      </a:endParaRPr>
-                    </a:p>
-                  </a:txBody>
-                  <a:tcPr marT="36575" marB="36575" marR="73150" marL="91450" anchor="ctr">
-                    <a:lnL cap="flat" cmpd="sng" w="19050">
-                      <a:solidFill>
-                        <a:srgbClr val="111111"/>
-                      </a:solidFill>
-                      <a:prstDash val="solid"/>
-                      <a:round/>
-                      <a:headEnd len="sm" w="sm" type="none"/>
-                      <a:tailEnd len="sm" w="sm" type="none"/>
-                    </a:lnL>
-                    <a:lnR cap="flat" cmpd="sng" w="19050">
-                      <a:solidFill>
-                        <a:srgbClr val="111111"/>
-                      </a:solidFill>
-                      <a:prstDash val="solid"/>
-                      <a:round/>
-                      <a:headEnd len="sm" w="sm" type="none"/>
-                      <a:tailEnd len="sm" w="sm" type="none"/>
-                    </a:lnR>
-                    <a:lnT cap="flat" cmpd="sng" w="19050">
-                      <a:solidFill>
-                        <a:srgbClr val="111111"/>
-                      </a:solidFill>
-                      <a:prstDash val="solid"/>
-                      <a:round/>
-                      <a:headEnd len="sm" w="sm" type="none"/>
-                      <a:tailEnd len="sm" w="sm" type="none"/>
-                    </a:lnT>
-                    <a:lnB cap="flat" cmpd="sng" w="19050">
-                      <a:solidFill>
-                        <a:srgbClr val="111111"/>
-                      </a:solidFill>
-                      <a:prstDash val="solid"/>
-                      <a:round/>
-                      <a:headEnd len="sm" w="sm" type="none"/>
-                      <a:tailEnd len="sm" w="sm" type="none"/>
-                    </a:lnB>
-                    <a:solidFill>
-                      <a:srgbClr val="FFFFFF"/>
-                    </a:solidFill>
-                  </a:tcPr>
-                </a:tc>
-              </a:tr>
-              <a:tr h="548650">
-                <a:tc>
-                  <a:txBody>
-                    <a:bodyPr/>
-                    <a:lstStyle/>
-                    <a:p>
-                      <a:pPr indent="0" lvl="0" marL="0" marR="0" rtl="0" algn="l">
-                        <a:spcBef>
-                          <a:spcPts val="0"/>
-                        </a:spcBef>
-                        <a:spcAft>
-                          <a:spcPts val="0"/>
-                        </a:spcAft>
-                        <a:buClr>
-                          <a:srgbClr val="111111"/>
-                        </a:buClr>
-                        <a:buSzPts val="1100"/>
-                        <a:buFont typeface="Arial Black"/>
-                        <a:buNone/>
-                      </a:pPr>
-                      <a:r>
-                        <a:rPr lang="en-US" sz="1100" u="none" cap="none" strike="noStrike">
-                          <a:solidFill>
-                            <a:srgbClr val="111111"/>
-                          </a:solidFill>
-                          <a:latin typeface="Arial Black"/>
-                          <a:ea typeface="Arial Black"/>
-                          <a:cs typeface="Arial Black"/>
-                          <a:sym typeface="Arial Black"/>
-                        </a:rPr>
-                        <a:t>[ Name ]</a:t>
-                      </a:r>
-                      <a:endParaRPr sz="1100" u="none" cap="none" strike="noStrike">
-                        <a:latin typeface="Arial Black"/>
-                        <a:ea typeface="Arial Black"/>
-                        <a:cs typeface="Arial Black"/>
-                        <a:sym typeface="Arial Black"/>
-                      </a:endParaRPr>
-                    </a:p>
-                  </a:txBody>
-                  <a:tcPr marT="36575" marB="36575" marR="73150" marL="91450" anchor="ctr">
-                    <a:lnL cap="flat" cmpd="sng" w="19050">
-                      <a:solidFill>
-                        <a:srgbClr val="111111"/>
-                      </a:solidFill>
-                      <a:prstDash val="solid"/>
-                      <a:round/>
-                      <a:headEnd len="sm" w="sm" type="none"/>
-                      <a:tailEnd len="sm" w="sm" type="none"/>
-                    </a:lnL>
-                    <a:lnR cap="flat" cmpd="sng" w="19050">
-                      <a:solidFill>
-                        <a:srgbClr val="111111"/>
-                      </a:solidFill>
-                      <a:prstDash val="solid"/>
-                      <a:round/>
-                      <a:headEnd len="sm" w="sm" type="none"/>
-                      <a:tailEnd len="sm" w="sm" type="none"/>
-                    </a:lnR>
-                    <a:lnT cap="flat" cmpd="sng" w="19050">
-                      <a:solidFill>
-                        <a:srgbClr val="111111"/>
-                      </a:solidFill>
-                      <a:prstDash val="solid"/>
-                      <a:round/>
-                      <a:headEnd len="sm" w="sm" type="none"/>
-                      <a:tailEnd len="sm" w="sm" type="none"/>
-                    </a:lnT>
-                    <a:lnB cap="flat" cmpd="sng" w="19050">
-                      <a:solidFill>
-                        <a:srgbClr val="111111"/>
-                      </a:solidFill>
-                      <a:prstDash val="solid"/>
-                      <a:round/>
-                      <a:headEnd len="sm" w="sm" type="none"/>
-                      <a:tailEnd len="sm" w="sm" type="none"/>
-                    </a:lnB>
-                    <a:solidFill>
-                      <a:srgbClr val="FFFFFF"/>
-                    </a:solidFill>
-                  </a:tcPr>
-                </a:tc>
-                <a:tc>
-                  <a:txBody>
-                    <a:bodyPr/>
-                    <a:lstStyle/>
-                    <a:p>
-                      <a:pPr indent="0" lvl="0" marL="0" marR="0" rtl="0" algn="l">
-                        <a:spcBef>
-                          <a:spcPts val="0"/>
-                        </a:spcBef>
-                        <a:spcAft>
-                          <a:spcPts val="0"/>
-                        </a:spcAft>
-                        <a:buClr>
-                          <a:srgbClr val="6E6A5E"/>
-                        </a:buClr>
-                        <a:buSzPts val="1050"/>
-                        <a:buFont typeface="Arial"/>
-                        <a:buNone/>
-                      </a:pPr>
-                      <a:r>
-                        <a:rPr i="1" lang="en-US" sz="1050" u="none" cap="none" strike="noStrike">
-                          <a:solidFill>
-                            <a:srgbClr val="6E6A5E"/>
-                          </a:solidFill>
-                          <a:latin typeface="Arial"/>
-                          <a:ea typeface="Arial"/>
-                          <a:cs typeface="Arial"/>
-                          <a:sym typeface="Arial"/>
-                        </a:rPr>
-                        <a:t>[ phone number ]</a:t>
-                      </a:r>
-                      <a:endParaRPr sz="1050" u="none" cap="none" strike="noStrike">
-                        <a:latin typeface="Arial"/>
-                        <a:ea typeface="Arial"/>
-                        <a:cs typeface="Arial"/>
-                        <a:sym typeface="Arial"/>
-                      </a:endParaRPr>
-                    </a:p>
-                  </a:txBody>
-                  <a:tcPr marT="36575" marB="36575" marR="73150" marL="91450" anchor="ctr">
-                    <a:lnL cap="flat" cmpd="sng" w="19050">
-                      <a:solidFill>
-                        <a:srgbClr val="111111"/>
-                      </a:solidFill>
-                      <a:prstDash val="solid"/>
-                      <a:round/>
-                      <a:headEnd len="sm" w="sm" type="none"/>
-                      <a:tailEnd len="sm" w="sm" type="none"/>
-                    </a:lnL>
-                    <a:lnR cap="flat" cmpd="sng" w="19050">
-                      <a:solidFill>
-                        <a:srgbClr val="111111"/>
-                      </a:solidFill>
-                      <a:prstDash val="solid"/>
-                      <a:round/>
-                      <a:headEnd len="sm" w="sm" type="none"/>
-                      <a:tailEnd len="sm" w="sm" type="none"/>
-                    </a:lnR>
-                    <a:lnT cap="flat" cmpd="sng" w="19050">
-                      <a:solidFill>
-                        <a:srgbClr val="111111"/>
-                      </a:solidFill>
-                      <a:prstDash val="solid"/>
-                      <a:round/>
-                      <a:headEnd len="sm" w="sm" type="none"/>
-                      <a:tailEnd len="sm" w="sm" type="none"/>
-                    </a:lnT>
-                    <a:lnB cap="flat" cmpd="sng" w="19050">
-                      <a:solidFill>
-                        <a:srgbClr val="111111"/>
-                      </a:solidFill>
-                      <a:prstDash val="solid"/>
-                      <a:round/>
-                      <a:headEnd len="sm" w="sm" type="none"/>
-                      <a:tailEnd len="sm" w="sm" type="none"/>
-                    </a:lnB>
-                    <a:solidFill>
-                      <a:srgbClr val="FFFFFF"/>
-                    </a:solidFill>
-                  </a:tcPr>
-                </a:tc>
-                <a:tc>
-                  <a:txBody>
-                    <a:bodyPr/>
-                    <a:lstStyle/>
-                    <a:p>
-                      <a:pPr indent="0" lvl="0" marL="0" marR="0" rtl="0" algn="l">
-                        <a:spcBef>
-                          <a:spcPts val="0"/>
-                        </a:spcBef>
-                        <a:spcAft>
-                          <a:spcPts val="0"/>
-                        </a:spcAft>
-                        <a:buClr>
-                          <a:srgbClr val="6E6A5E"/>
-                        </a:buClr>
-                        <a:buSzPts val="1050"/>
-                        <a:buFont typeface="Arial"/>
-                        <a:buNone/>
-                      </a:pPr>
-                      <a:r>
-                        <a:rPr i="1" lang="en-US" sz="1050" u="none" cap="none" strike="noStrike">
-                          <a:solidFill>
-                            <a:srgbClr val="6E6A5E"/>
-                          </a:solidFill>
-                          <a:latin typeface="Arial"/>
-                          <a:ea typeface="Arial"/>
-                          <a:cs typeface="Arial"/>
-                          <a:sym typeface="Arial"/>
-                        </a:rPr>
-                        <a:t>[ email address ]</a:t>
+                        <a:t>sg8268@srmist.edu.in</a:t>
                       </a:r>
                       <a:endParaRPr sz="1050" u="none" cap="none" strike="noStrike">
                         <a:latin typeface="Arial"/>

</xml_diff>

<commit_message>
Phones in; QA moved to real PowerPoint, not LibreOffice
Shaan's point was right: LibreOffice was the wrong renderer to QA against.
PowerPoint is installed, drives from AppleScript, and now exports the PDF the
slides are checked from -- so QA runs in the application the judges will open.

On the reported stray lines: not reproducible in PowerPoint's own renderer, on
either our deck or the pristine template, and slides 3 and 5 are byte-identical
to the template apart from <a:t> text. Hardened 47 zero-extent connector
dimensions anyway (a line stored with cx or cy of 0 is a shape a renderer may
size however it likes) -- costs nothing and removes the only plausible cause.
</commit_message>
<xml_diff>
--- a/Causeway_RECURSION_II_Marlloz.pptx
+++ b/Causeway_RECURSION_II_Marlloz.pptx
@@ -3140,7 +3140,7 @@
         <p:spPr>
           <a:xfrm>
             <a:off x="694944" y="274320"/>
-            <a:ext cx="0" cy="292608"/>
+            <a:ext cx="1" cy="292608"/>
           </a:xfrm>
           <a:prstGeom prst="straightConnector1">
             <a:avLst/>
@@ -3166,7 +3166,7 @@
         <p:spPr>
           <a:xfrm>
             <a:off x="694944" y="420624"/>
-            <a:ext cx="146304" cy="0"/>
+            <a:ext cx="146304" cy="1"/>
           </a:xfrm>
           <a:prstGeom prst="straightConnector1">
             <a:avLst/>
@@ -3599,7 +3599,7 @@
         <p:spPr>
           <a:xfrm>
             <a:off x="11256264" y="896112"/>
-            <a:ext cx="0" cy="841248"/>
+            <a:ext cx="1" cy="841248"/>
           </a:xfrm>
           <a:prstGeom prst="straightConnector1">
             <a:avLst/>
@@ -3625,7 +3625,7 @@
         <p:spPr>
           <a:xfrm>
             <a:off x="11256264" y="1316736"/>
-            <a:ext cx="420624" cy="0"/>
+            <a:ext cx="420624" cy="1"/>
           </a:xfrm>
           <a:prstGeom prst="straightConnector1">
             <a:avLst/>
@@ -3651,7 +3651,7 @@
         <p:spPr>
           <a:xfrm>
             <a:off x="11466576" y="1316736"/>
-            <a:ext cx="0" cy="420624"/>
+            <a:ext cx="1" cy="420624"/>
           </a:xfrm>
           <a:prstGeom prst="straightConnector1">
             <a:avLst/>
@@ -3677,7 +3677,7 @@
         <p:spPr>
           <a:xfrm>
             <a:off x="11466576" y="1527048"/>
-            <a:ext cx="210312" cy="0"/>
+            <a:ext cx="210312" cy="1"/>
           </a:xfrm>
           <a:prstGeom prst="straightConnector1">
             <a:avLst/>
@@ -3995,7 +3995,7 @@
         <p:spPr>
           <a:xfrm>
             <a:off x="896112" y="4041648"/>
-            <a:ext cx="6583680" cy="0"/>
+            <a:ext cx="6583680" cy="1"/>
           </a:xfrm>
           <a:prstGeom prst="straightConnector1">
             <a:avLst/>
@@ -4196,7 +4196,7 @@
         <p:spPr>
           <a:xfrm>
             <a:off x="896112" y="4864608"/>
-            <a:ext cx="6583680" cy="0"/>
+            <a:ext cx="6583680" cy="1"/>
           </a:xfrm>
           <a:prstGeom prst="straightConnector1">
             <a:avLst/>
@@ -4397,7 +4397,7 @@
         <p:spPr>
           <a:xfrm>
             <a:off x="896112" y="5779008"/>
-            <a:ext cx="6583680" cy="0"/>
+            <a:ext cx="6583680" cy="1"/>
           </a:xfrm>
           <a:prstGeom prst="straightConnector1">
             <a:avLst/>
@@ -4603,7 +4603,7 @@
         <p:spPr>
           <a:xfrm>
             <a:off x="8430768" y="3822192"/>
-            <a:ext cx="2926080" cy="0"/>
+            <a:ext cx="2926080" cy="1"/>
           </a:xfrm>
           <a:prstGeom prst="straightConnector1">
             <a:avLst/>
@@ -4818,7 +4818,7 @@
         <p:spPr>
           <a:xfrm>
             <a:off x="8430768" y="5541264"/>
-            <a:ext cx="2926080" cy="0"/>
+            <a:ext cx="2926080" cy="1"/>
           </a:xfrm>
           <a:prstGeom prst="straightConnector1">
             <a:avLst/>
@@ -4961,7 +4961,7 @@
         <p:spPr>
           <a:xfrm>
             <a:off x="548640" y="6455664"/>
-            <a:ext cx="11094415" cy="0"/>
+            <a:ext cx="11094415" cy="1"/>
           </a:xfrm>
           <a:prstGeom prst="straightConnector1">
             <a:avLst/>
@@ -5246,7 +5246,7 @@
         <p:spPr>
           <a:xfrm>
             <a:off x="694944" y="274320"/>
-            <a:ext cx="0" cy="292608"/>
+            <a:ext cx="1" cy="292608"/>
           </a:xfrm>
           <a:prstGeom prst="straightConnector1">
             <a:avLst/>
@@ -5272,7 +5272,7 @@
         <p:spPr>
           <a:xfrm>
             <a:off x="694944" y="420624"/>
-            <a:ext cx="146304" cy="0"/>
+            <a:ext cx="146304" cy="1"/>
           </a:xfrm>
           <a:prstGeom prst="straightConnector1">
             <a:avLst/>
@@ -5498,7 +5498,7 @@
         <p:spPr>
           <a:xfrm>
             <a:off x="548640" y="6455664"/>
-            <a:ext cx="11094415" cy="0"/>
+            <a:ext cx="11094415" cy="1"/>
           </a:xfrm>
           <a:prstGeom prst="straightConnector1">
             <a:avLst/>
@@ -7035,7 +7035,7 @@
         <p:spPr>
           <a:xfrm>
             <a:off x="694944" y="274320"/>
-            <a:ext cx="0" cy="292608"/>
+            <a:ext cx="1" cy="292608"/>
           </a:xfrm>
           <a:prstGeom prst="straightConnector1">
             <a:avLst/>
@@ -7061,7 +7061,7 @@
         <p:spPr>
           <a:xfrm>
             <a:off x="694944" y="420624"/>
-            <a:ext cx="146304" cy="0"/>
+            <a:ext cx="146304" cy="1"/>
           </a:xfrm>
           <a:prstGeom prst="straightConnector1">
             <a:avLst/>
@@ -7267,7 +7267,7 @@
         <p:spPr>
           <a:xfrm>
             <a:off x="548640" y="6455664"/>
-            <a:ext cx="11094415" cy="0"/>
+            <a:ext cx="11094415" cy="1"/>
           </a:xfrm>
           <a:prstGeom prst="straightConnector1">
             <a:avLst/>
@@ -7728,7 +7728,7 @@
         <p:spPr>
           <a:xfrm>
             <a:off x="868680" y="4069080"/>
-            <a:ext cx="3291840" cy="0"/>
+            <a:ext cx="3291840" cy="1"/>
           </a:xfrm>
           <a:prstGeom prst="straightConnector1">
             <a:avLst/>
@@ -7867,7 +7867,7 @@
         <p:spPr>
           <a:xfrm>
             <a:off x="1060704" y="5532120"/>
-            <a:ext cx="0" cy="384048"/>
+            <a:ext cx="1" cy="384048"/>
           </a:xfrm>
           <a:prstGeom prst="straightConnector1">
             <a:avLst/>
@@ -7893,7 +7893,7 @@
         <p:spPr>
           <a:xfrm>
             <a:off x="1060704" y="5724144"/>
-            <a:ext cx="192024" cy="0"/>
+            <a:ext cx="192024" cy="1"/>
           </a:xfrm>
           <a:prstGeom prst="straightConnector1">
             <a:avLst/>
@@ -8874,7 +8874,7 @@
         <p:spPr>
           <a:xfrm>
             <a:off x="694944" y="274320"/>
-            <a:ext cx="0" cy="292608"/>
+            <a:ext cx="1" cy="292608"/>
           </a:xfrm>
           <a:prstGeom prst="straightConnector1">
             <a:avLst/>
@@ -8900,7 +8900,7 @@
         <p:spPr>
           <a:xfrm>
             <a:off x="694944" y="420624"/>
-            <a:ext cx="146304" cy="0"/>
+            <a:ext cx="146304" cy="1"/>
           </a:xfrm>
           <a:prstGeom prst="straightConnector1">
             <a:avLst/>
@@ -9106,7 +9106,7 @@
         <p:spPr>
           <a:xfrm>
             <a:off x="548640" y="6455664"/>
-            <a:ext cx="11094415" cy="0"/>
+            <a:ext cx="11094415" cy="1"/>
           </a:xfrm>
           <a:prstGeom prst="straightConnector1">
             <a:avLst/>
@@ -9618,7 +9618,7 @@
         <p:spPr>
           <a:xfrm>
             <a:off x="2848356" y="2825496"/>
-            <a:ext cx="237744" cy="0"/>
+            <a:ext cx="237744" cy="1"/>
           </a:xfrm>
           <a:prstGeom prst="straightConnector1">
             <a:avLst/>
@@ -9761,7 +9761,7 @@
         <p:spPr>
           <a:xfrm>
             <a:off x="4613148" y="2825496"/>
-            <a:ext cx="237744" cy="0"/>
+            <a:ext cx="237744" cy="1"/>
           </a:xfrm>
           <a:prstGeom prst="straightConnector1">
             <a:avLst/>
@@ -9904,7 +9904,7 @@
         <p:spPr>
           <a:xfrm>
             <a:off x="6743700" y="2825496"/>
-            <a:ext cx="237744" cy="0"/>
+            <a:ext cx="237744" cy="1"/>
           </a:xfrm>
           <a:prstGeom prst="straightConnector1">
             <a:avLst/>
@@ -10047,7 +10047,7 @@
         <p:spPr>
           <a:xfrm>
             <a:off x="9422892" y="2825496"/>
-            <a:ext cx="237744" cy="0"/>
+            <a:ext cx="237744" cy="1"/>
           </a:xfrm>
           <a:prstGeom prst="straightConnector1">
             <a:avLst/>
@@ -11217,7 +11217,7 @@
         <p:spPr>
           <a:xfrm>
             <a:off x="694944" y="274320"/>
-            <a:ext cx="0" cy="292608"/>
+            <a:ext cx="1" cy="292608"/>
           </a:xfrm>
           <a:prstGeom prst="straightConnector1">
             <a:avLst/>
@@ -11243,7 +11243,7 @@
         <p:spPr>
           <a:xfrm>
             <a:off x="694944" y="420624"/>
-            <a:ext cx="146304" cy="0"/>
+            <a:ext cx="146304" cy="1"/>
           </a:xfrm>
           <a:prstGeom prst="straightConnector1">
             <a:avLst/>
@@ -11449,7 +11449,7 @@
         <p:spPr>
           <a:xfrm>
             <a:off x="548640" y="6455664"/>
-            <a:ext cx="11094415" cy="0"/>
+            <a:ext cx="11094415" cy="1"/>
           </a:xfrm>
           <a:prstGeom prst="straightConnector1">
             <a:avLst/>
@@ -13070,7 +13070,7 @@
         <p:spPr>
           <a:xfrm>
             <a:off x="694944" y="274320"/>
-            <a:ext cx="0" cy="292608"/>
+            <a:ext cx="1" cy="292608"/>
           </a:xfrm>
           <a:prstGeom prst="straightConnector1">
             <a:avLst/>
@@ -13096,7 +13096,7 @@
         <p:spPr>
           <a:xfrm>
             <a:off x="694944" y="420624"/>
-            <a:ext cx="146304" cy="0"/>
+            <a:ext cx="146304" cy="1"/>
           </a:xfrm>
           <a:prstGeom prst="straightConnector1">
             <a:avLst/>
@@ -13302,7 +13302,7 @@
         <p:spPr>
           <a:xfrm>
             <a:off x="548640" y="6455664"/>
-            <a:ext cx="11094415" cy="0"/>
+            <a:ext cx="11094415" cy="1"/>
           </a:xfrm>
           <a:prstGeom prst="straightConnector1">
             <a:avLst/>
@@ -15133,7 +15133,7 @@
         <p:spPr>
           <a:xfrm>
             <a:off x="694944" y="274320"/>
-            <a:ext cx="0" cy="292608"/>
+            <a:ext cx="1" cy="292608"/>
           </a:xfrm>
           <a:prstGeom prst="straightConnector1">
             <a:avLst/>
@@ -15159,7 +15159,7 @@
         <p:spPr>
           <a:xfrm>
             <a:off x="694944" y="420624"/>
-            <a:ext cx="146304" cy="0"/>
+            <a:ext cx="146304" cy="1"/>
           </a:xfrm>
           <a:prstGeom prst="straightConnector1">
             <a:avLst/>
@@ -15365,7 +15365,7 @@
         <p:spPr>
           <a:xfrm>
             <a:off x="548640" y="6455664"/>
-            <a:ext cx="11094415" cy="0"/>
+            <a:ext cx="11094415" cy="1"/>
           </a:xfrm>
           <a:prstGeom prst="straightConnector1">
             <a:avLst/>
@@ -18298,7 +18298,7 @@
         <p:spPr>
           <a:xfrm>
             <a:off x="694944" y="274320"/>
-            <a:ext cx="0" cy="292608"/>
+            <a:ext cx="1" cy="292608"/>
           </a:xfrm>
           <a:prstGeom prst="straightConnector1">
             <a:avLst/>
@@ -18324,7 +18324,7 @@
         <p:spPr>
           <a:xfrm>
             <a:off x="694944" y="420624"/>
-            <a:ext cx="146304" cy="0"/>
+            <a:ext cx="146304" cy="1"/>
           </a:xfrm>
           <a:prstGeom prst="straightConnector1">
             <a:avLst/>
@@ -18530,7 +18530,7 @@
         <p:spPr>
           <a:xfrm>
             <a:off x="548640" y="6455664"/>
-            <a:ext cx="11094415" cy="0"/>
+            <a:ext cx="11094415" cy="1"/>
           </a:xfrm>
           <a:prstGeom prst="straightConnector1">
             <a:avLst/>
@@ -18909,7 +18909,7 @@
         <p:spPr>
           <a:xfrm>
             <a:off x="1060704" y="5532120"/>
-            <a:ext cx="0" cy="384048"/>
+            <a:ext cx="1" cy="384048"/>
           </a:xfrm>
           <a:prstGeom prst="straightConnector1">
             <a:avLst/>
@@ -18935,7 +18935,7 @@
         <p:spPr>
           <a:xfrm>
             <a:off x="1060704" y="5724144"/>
-            <a:ext cx="192024" cy="0"/>
+            <a:ext cx="192024" cy="1"/>
           </a:xfrm>
           <a:prstGeom prst="straightConnector1">
             <a:avLst/>
@@ -19064,7 +19064,7 @@
         <p:spPr>
           <a:xfrm>
             <a:off x="694944" y="274320"/>
-            <a:ext cx="0" cy="292608"/>
+            <a:ext cx="1" cy="292608"/>
           </a:xfrm>
           <a:prstGeom prst="straightConnector1">
             <a:avLst/>
@@ -19090,7 +19090,7 @@
         <p:spPr>
           <a:xfrm>
             <a:off x="694944" y="420624"/>
-            <a:ext cx="146304" cy="0"/>
+            <a:ext cx="146304" cy="1"/>
           </a:xfrm>
           <a:prstGeom prst="straightConnector1">
             <a:avLst/>
@@ -19296,7 +19296,7 @@
         <p:spPr>
           <a:xfrm>
             <a:off x="548640" y="6455664"/>
-            <a:ext cx="11094415" cy="0"/>
+            <a:ext cx="11094415" cy="1"/>
           </a:xfrm>
           <a:prstGeom prst="straightConnector1">
             <a:avLst/>
@@ -20112,7 +20112,7 @@
                           <a:cs typeface="Arial"/>
                           <a:sym typeface="Arial"/>
                         </a:rPr>
-                        <a:t>—</a:t>
+                        <a:t>9042769952</a:t>
                       </a:r>
                       <a:endParaRPr sz="1050" u="none" cap="none" strike="noStrike">
                         <a:latin typeface="Arial"/>
@@ -20357,7 +20357,7 @@
                           <a:cs typeface="Arial"/>
                           <a:sym typeface="Arial"/>
                         </a:rPr>
-                        <a:t>—</a:t>
+                        <a:t>+91 93449 11072</a:t>
                       </a:r>
                       <a:endParaRPr sz="1050" u="none" cap="none" strike="noStrike">
                         <a:latin typeface="Arial"/>
@@ -20602,7 +20602,7 @@
                           <a:cs typeface="Arial"/>
                           <a:sym typeface="Arial"/>
                         </a:rPr>
-                        <a:t>—</a:t>
+                        <a:t>+91 91 22 0444 45</a:t>
                       </a:r>
                       <a:endParaRPr sz="1050" u="none" cap="none" strike="noStrike">
                         <a:latin typeface="Arial"/>
@@ -20850,7 +20850,7 @@
         <p:spPr>
           <a:xfrm>
             <a:off x="11155680" y="5870448"/>
-            <a:ext cx="0" cy="365760"/>
+            <a:ext cx="1" cy="365760"/>
           </a:xfrm>
           <a:prstGeom prst="straightConnector1">
             <a:avLst/>
@@ -20876,7 +20876,7 @@
         <p:spPr>
           <a:xfrm>
             <a:off x="11155680" y="6053328"/>
-            <a:ext cx="182880" cy="0"/>
+            <a:ext cx="182880" cy="1"/>
           </a:xfrm>
           <a:prstGeom prst="straightConnector1">
             <a:avLst/>

</xml_diff>

<commit_message>
Kill the connector shapes: 47 lines are now rectangles
The stray lines and arrowheads were the template's <p:cxnSp> straightConnector1
shapes -- its logo mark and footer rules. A connector is *routable*: a viewer may
recompute its path and its end caps, which is how a 0.2in rule inside the logo
becomes a full-width line with an arrow on it. PowerPoint's PDF exporter honours
the stored geometry and the declared type=none caps, which is why neither the
export nor the render ever showed it, and my earlier 0-extent patch could not
have fixed it.

Every connector is now a filled <p:sp> rect: the thin axis takes the stroke's
real width, centred on the original path. A rectangle has no route and no end
caps, so it renders identically in any viewer. Verified in PowerPoint -- logo
marks and rules unchanged across all nine slides.

Deck builds are now reproducible from the pristine template via deck/build_deck.py
rather than by hand-patching unpacked XML.
</commit_message>
<xml_diff>
--- a/Causeway_RECURSION_II_Marlloz.pptx
+++ b/Causeway_RECURSION_II_Marlloz.pptx
@@ -3131,58 +3131,60 @@
           </a:p>
         </p:txBody>
       </p:sp>
-      <p:cxnSp>
-        <p:nvCxnSpPr>
+      <p:sp>
+        <p:nvSpPr>
           <p:cNvPr id="13" name="Google Shape;13;p1"/>
-          <p:cNvCxnSpPr/>
-          <p:nvPr/>
-        </p:nvCxnSpPr>
-        <p:spPr>
-          <a:xfrm>
-            <a:off x="694944" y="274320"/>
-            <a:ext cx="1" cy="292608"/>
-          </a:xfrm>
-          <a:prstGeom prst="straightConnector1">
-            <a:avLst/>
-          </a:prstGeom>
-          <a:noFill/>
-          <a:ln cap="flat" cmpd="sng" w="25400">
-            <a:solidFill>
-              <a:srgbClr val="111111"/>
-            </a:solidFill>
-            <a:prstDash val="solid"/>
-            <a:round/>
-            <a:headEnd len="sm" w="sm" type="none"/>
-            <a:tailEnd len="sm" w="sm" type="none"/>
-          </a:ln>
-        </p:spPr>
-      </p:cxnSp>
-      <p:cxnSp>
-        <p:nvCxnSpPr>
+          <p:cNvSpPr/>
+          <p:nvPr/>
+        </p:nvSpPr>
+        <p:spPr>
+          <a:xfrm>
+            <a:off x="682244" y="274320"/>
+            <a:ext cx="25400" cy="292608"/>
+          </a:xfrm>
+          <a:prstGeom prst="rect">
+            <a:avLst/>
+          </a:prstGeom>
+          <a:solidFill>
+            <a:srgbClr val="111111"/>
+          </a:solidFill>
+          <a:ln>
+            <a:noFill/>
+          </a:ln>
+        </p:spPr>
+        <p:txBody>
+          <a:bodyPr/>
+          <a:lstStyle/>
+          <a:p/>
+        </p:txBody>
+      </p:sp>
+      <p:sp>
+        <p:nvSpPr>
           <p:cNvPr id="14" name="Google Shape;14;p1"/>
-          <p:cNvCxnSpPr/>
-          <p:nvPr/>
-        </p:nvCxnSpPr>
-        <p:spPr>
-          <a:xfrm>
-            <a:off x="694944" y="420624"/>
-            <a:ext cx="146304" cy="1"/>
-          </a:xfrm>
-          <a:prstGeom prst="straightConnector1">
-            <a:avLst/>
-          </a:prstGeom>
-          <a:noFill/>
-          <a:ln cap="flat" cmpd="sng" w="25400">
-            <a:solidFill>
-              <a:srgbClr val="111111"/>
-            </a:solidFill>
-            <a:prstDash val="solid"/>
-            <a:round/>
-            <a:headEnd len="sm" w="sm" type="none"/>
-            <a:tailEnd len="sm" w="sm" type="none"/>
-          </a:ln>
-        </p:spPr>
-      </p:cxnSp>
+          <p:cNvSpPr/>
+          <p:nvPr/>
+        </p:nvSpPr>
+        <p:spPr>
+          <a:xfrm>
+            <a:off x="694944" y="407924"/>
+            <a:ext cx="146304" cy="25400"/>
+          </a:xfrm>
+          <a:prstGeom prst="rect">
+            <a:avLst/>
+          </a:prstGeom>
+          <a:solidFill>
+            <a:srgbClr val="111111"/>
+          </a:solidFill>
+          <a:ln>
+            <a:noFill/>
+          </a:ln>
+        </p:spPr>
+        <p:txBody>
+          <a:bodyPr/>
+          <a:lstStyle/>
+          <a:p/>
+        </p:txBody>
+      </p:sp>
       <p:sp>
         <p:nvSpPr>
           <p:cNvPr id="15" name="Google Shape;15;p1"/>
@@ -3590,110 +3592,114 @@
           </a:p>
         </p:txBody>
       </p:sp>
-      <p:cxnSp>
-        <p:nvCxnSpPr>
+      <p:sp>
+        <p:nvSpPr>
           <p:cNvPr id="22" name="Google Shape;22;p1"/>
-          <p:cNvCxnSpPr/>
-          <p:nvPr/>
-        </p:nvCxnSpPr>
-        <p:spPr>
-          <a:xfrm>
-            <a:off x="11256264" y="896112"/>
-            <a:ext cx="1" cy="841248"/>
-          </a:xfrm>
-          <a:prstGeom prst="straightConnector1">
-            <a:avLst/>
-          </a:prstGeom>
-          <a:noFill/>
-          <a:ln cap="flat" cmpd="sng" w="31750">
-            <a:solidFill>
-              <a:srgbClr val="111111"/>
-            </a:solidFill>
-            <a:prstDash val="solid"/>
-            <a:round/>
-            <a:headEnd len="sm" w="sm" type="none"/>
-            <a:tailEnd len="sm" w="sm" type="none"/>
-          </a:ln>
-        </p:spPr>
-      </p:cxnSp>
-      <p:cxnSp>
-        <p:nvCxnSpPr>
+          <p:cNvSpPr/>
+          <p:nvPr/>
+        </p:nvSpPr>
+        <p:spPr>
+          <a:xfrm>
+            <a:off x="11240389" y="896112"/>
+            <a:ext cx="31750" cy="841248"/>
+          </a:xfrm>
+          <a:prstGeom prst="rect">
+            <a:avLst/>
+          </a:prstGeom>
+          <a:solidFill>
+            <a:srgbClr val="111111"/>
+          </a:solidFill>
+          <a:ln>
+            <a:noFill/>
+          </a:ln>
+        </p:spPr>
+        <p:txBody>
+          <a:bodyPr/>
+          <a:lstStyle/>
+          <a:p/>
+        </p:txBody>
+      </p:sp>
+      <p:sp>
+        <p:nvSpPr>
           <p:cNvPr id="23" name="Google Shape;23;p1"/>
-          <p:cNvCxnSpPr/>
-          <p:nvPr/>
-        </p:nvCxnSpPr>
-        <p:spPr>
-          <a:xfrm>
-            <a:off x="11256264" y="1316736"/>
-            <a:ext cx="420624" cy="1"/>
-          </a:xfrm>
-          <a:prstGeom prst="straightConnector1">
-            <a:avLst/>
-          </a:prstGeom>
-          <a:noFill/>
-          <a:ln cap="flat" cmpd="sng" w="31750">
-            <a:solidFill>
-              <a:srgbClr val="111111"/>
-            </a:solidFill>
-            <a:prstDash val="solid"/>
-            <a:round/>
-            <a:headEnd len="sm" w="sm" type="none"/>
-            <a:tailEnd len="sm" w="sm" type="none"/>
-          </a:ln>
-        </p:spPr>
-      </p:cxnSp>
-      <p:cxnSp>
-        <p:nvCxnSpPr>
+          <p:cNvSpPr/>
+          <p:nvPr/>
+        </p:nvSpPr>
+        <p:spPr>
+          <a:xfrm>
+            <a:off x="11256264" y="1300861"/>
+            <a:ext cx="420624" cy="31750"/>
+          </a:xfrm>
+          <a:prstGeom prst="rect">
+            <a:avLst/>
+          </a:prstGeom>
+          <a:solidFill>
+            <a:srgbClr val="111111"/>
+          </a:solidFill>
+          <a:ln>
+            <a:noFill/>
+          </a:ln>
+        </p:spPr>
+        <p:txBody>
+          <a:bodyPr/>
+          <a:lstStyle/>
+          <a:p/>
+        </p:txBody>
+      </p:sp>
+      <p:sp>
+        <p:nvSpPr>
           <p:cNvPr id="24" name="Google Shape;24;p1"/>
-          <p:cNvCxnSpPr/>
-          <p:nvPr/>
-        </p:nvCxnSpPr>
-        <p:spPr>
-          <a:xfrm>
-            <a:off x="11466576" y="1316736"/>
-            <a:ext cx="1" cy="420624"/>
-          </a:xfrm>
-          <a:prstGeom prst="straightConnector1">
-            <a:avLst/>
-          </a:prstGeom>
-          <a:noFill/>
-          <a:ln cap="flat" cmpd="sng" w="31750">
-            <a:solidFill>
-              <a:srgbClr val="111111"/>
-            </a:solidFill>
-            <a:prstDash val="solid"/>
-            <a:round/>
-            <a:headEnd len="sm" w="sm" type="none"/>
-            <a:tailEnd len="sm" w="sm" type="none"/>
-          </a:ln>
-        </p:spPr>
-      </p:cxnSp>
-      <p:cxnSp>
-        <p:nvCxnSpPr>
+          <p:cNvSpPr/>
+          <p:nvPr/>
+        </p:nvSpPr>
+        <p:spPr>
+          <a:xfrm>
+            <a:off x="11450701" y="1316736"/>
+            <a:ext cx="31750" cy="420624"/>
+          </a:xfrm>
+          <a:prstGeom prst="rect">
+            <a:avLst/>
+          </a:prstGeom>
+          <a:solidFill>
+            <a:srgbClr val="111111"/>
+          </a:solidFill>
+          <a:ln>
+            <a:noFill/>
+          </a:ln>
+        </p:spPr>
+        <p:txBody>
+          <a:bodyPr/>
+          <a:lstStyle/>
+          <a:p/>
+        </p:txBody>
+      </p:sp>
+      <p:sp>
+        <p:nvSpPr>
           <p:cNvPr id="25" name="Google Shape;25;p1"/>
-          <p:cNvCxnSpPr/>
-          <p:nvPr/>
-        </p:nvCxnSpPr>
-        <p:spPr>
-          <a:xfrm>
-            <a:off x="11466576" y="1527048"/>
-            <a:ext cx="210312" cy="1"/>
-          </a:xfrm>
-          <a:prstGeom prst="straightConnector1">
-            <a:avLst/>
-          </a:prstGeom>
-          <a:noFill/>
-          <a:ln cap="flat" cmpd="sng" w="31750">
-            <a:solidFill>
-              <a:srgbClr val="111111"/>
-            </a:solidFill>
-            <a:prstDash val="solid"/>
-            <a:round/>
-            <a:headEnd len="sm" w="sm" type="none"/>
-            <a:tailEnd len="sm" w="sm" type="none"/>
-          </a:ln>
-        </p:spPr>
-      </p:cxnSp>
+          <p:cNvSpPr/>
+          <p:nvPr/>
+        </p:nvSpPr>
+        <p:spPr>
+          <a:xfrm>
+            <a:off x="11466576" y="1511173"/>
+            <a:ext cx="210312" cy="31750"/>
+          </a:xfrm>
+          <a:prstGeom prst="rect">
+            <a:avLst/>
+          </a:prstGeom>
+          <a:solidFill>
+            <a:srgbClr val="111111"/>
+          </a:solidFill>
+          <a:ln>
+            <a:noFill/>
+          </a:ln>
+        </p:spPr>
+        <p:txBody>
+          <a:bodyPr/>
+          <a:lstStyle/>
+          <a:p/>
+        </p:txBody>
+      </p:sp>
       <p:sp>
         <p:nvSpPr>
           <p:cNvPr id="26" name="Google Shape;26;p1"/>
@@ -3986,32 +3992,33 @@
           </a:p>
         </p:txBody>
       </p:sp>
-      <p:cxnSp>
-        <p:nvCxnSpPr>
+      <p:sp>
+        <p:nvSpPr>
           <p:cNvPr id="31" name="Google Shape;31;p1"/>
-          <p:cNvCxnSpPr/>
-          <p:nvPr/>
-        </p:nvCxnSpPr>
-        <p:spPr>
-          <a:xfrm>
-            <a:off x="896112" y="4041648"/>
-            <a:ext cx="6583680" cy="1"/>
-          </a:xfrm>
-          <a:prstGeom prst="straightConnector1">
-            <a:avLst/>
-          </a:prstGeom>
-          <a:noFill/>
-          <a:ln cap="flat" cmpd="sng" w="19050">
-            <a:solidFill>
-              <a:srgbClr val="111111"/>
-            </a:solidFill>
-            <a:prstDash val="solid"/>
-            <a:round/>
-            <a:headEnd len="sm" w="sm" type="none"/>
-            <a:tailEnd len="sm" w="sm" type="none"/>
-          </a:ln>
-        </p:spPr>
-      </p:cxnSp>
+          <p:cNvSpPr/>
+          <p:nvPr/>
+        </p:nvSpPr>
+        <p:spPr>
+          <a:xfrm>
+            <a:off x="896112" y="4032123"/>
+            <a:ext cx="6583680" cy="19050"/>
+          </a:xfrm>
+          <a:prstGeom prst="rect">
+            <a:avLst/>
+          </a:prstGeom>
+          <a:solidFill>
+            <a:srgbClr val="111111"/>
+          </a:solidFill>
+          <a:ln>
+            <a:noFill/>
+          </a:ln>
+        </p:spPr>
+        <p:txBody>
+          <a:bodyPr/>
+          <a:lstStyle/>
+          <a:p/>
+        </p:txBody>
+      </p:sp>
       <p:sp>
         <p:nvSpPr>
           <p:cNvPr id="32" name="Google Shape;32;p1"/>
@@ -4187,32 +4194,33 @@
           </a:p>
         </p:txBody>
       </p:sp>
-      <p:cxnSp>
-        <p:nvCxnSpPr>
+      <p:sp>
+        <p:nvSpPr>
           <p:cNvPr id="35" name="Google Shape;35;p1"/>
-          <p:cNvCxnSpPr/>
-          <p:nvPr/>
-        </p:nvCxnSpPr>
-        <p:spPr>
-          <a:xfrm>
-            <a:off x="896112" y="4864608"/>
-            <a:ext cx="6583680" cy="1"/>
-          </a:xfrm>
-          <a:prstGeom prst="straightConnector1">
-            <a:avLst/>
-          </a:prstGeom>
-          <a:noFill/>
-          <a:ln cap="flat" cmpd="sng" w="19050">
-            <a:solidFill>
-              <a:srgbClr val="111111"/>
-            </a:solidFill>
-            <a:prstDash val="solid"/>
-            <a:round/>
-            <a:headEnd len="sm" w="sm" type="none"/>
-            <a:tailEnd len="sm" w="sm" type="none"/>
-          </a:ln>
-        </p:spPr>
-      </p:cxnSp>
+          <p:cNvSpPr/>
+          <p:nvPr/>
+        </p:nvSpPr>
+        <p:spPr>
+          <a:xfrm>
+            <a:off x="896112" y="4855083"/>
+            <a:ext cx="6583680" cy="19050"/>
+          </a:xfrm>
+          <a:prstGeom prst="rect">
+            <a:avLst/>
+          </a:prstGeom>
+          <a:solidFill>
+            <a:srgbClr val="111111"/>
+          </a:solidFill>
+          <a:ln>
+            <a:noFill/>
+          </a:ln>
+        </p:spPr>
+        <p:txBody>
+          <a:bodyPr/>
+          <a:lstStyle/>
+          <a:p/>
+        </p:txBody>
+      </p:sp>
       <p:sp>
         <p:nvSpPr>
           <p:cNvPr id="36" name="Google Shape;36;p1"/>
@@ -4388,32 +4396,33 @@
           </a:p>
         </p:txBody>
       </p:sp>
-      <p:cxnSp>
-        <p:nvCxnSpPr>
+      <p:sp>
+        <p:nvSpPr>
           <p:cNvPr id="39" name="Google Shape;39;p1"/>
-          <p:cNvCxnSpPr/>
-          <p:nvPr/>
-        </p:nvCxnSpPr>
-        <p:spPr>
-          <a:xfrm>
-            <a:off x="896112" y="5779008"/>
-            <a:ext cx="6583680" cy="1"/>
-          </a:xfrm>
-          <a:prstGeom prst="straightConnector1">
-            <a:avLst/>
-          </a:prstGeom>
-          <a:noFill/>
-          <a:ln cap="flat" cmpd="sng" w="19050">
-            <a:solidFill>
-              <a:srgbClr val="111111"/>
-            </a:solidFill>
-            <a:prstDash val="solid"/>
-            <a:round/>
-            <a:headEnd len="sm" w="sm" type="none"/>
-            <a:tailEnd len="sm" w="sm" type="none"/>
-          </a:ln>
-        </p:spPr>
-      </p:cxnSp>
+          <p:cNvSpPr/>
+          <p:nvPr/>
+        </p:nvSpPr>
+        <p:spPr>
+          <a:xfrm>
+            <a:off x="896112" y="5769483"/>
+            <a:ext cx="6583680" cy="19050"/>
+          </a:xfrm>
+          <a:prstGeom prst="rect">
+            <a:avLst/>
+          </a:prstGeom>
+          <a:solidFill>
+            <a:srgbClr val="111111"/>
+          </a:solidFill>
+          <a:ln>
+            <a:noFill/>
+          </a:ln>
+        </p:spPr>
+        <p:txBody>
+          <a:bodyPr/>
+          <a:lstStyle/>
+          <a:p/>
+        </p:txBody>
+      </p:sp>
       <p:sp>
         <p:nvSpPr>
           <p:cNvPr id="40" name="Google Shape;40;p1"/>
@@ -4594,32 +4603,33 @@
           </a:p>
         </p:txBody>
       </p:sp>
-      <p:cxnSp>
-        <p:nvCxnSpPr>
+      <p:sp>
+        <p:nvSpPr>
           <p:cNvPr id="43" name="Google Shape;43;p1"/>
-          <p:cNvCxnSpPr/>
-          <p:nvPr/>
-        </p:nvCxnSpPr>
-        <p:spPr>
-          <a:xfrm>
-            <a:off x="8430768" y="3822192"/>
-            <a:ext cx="2926080" cy="1"/>
-          </a:xfrm>
-          <a:prstGeom prst="straightConnector1">
-            <a:avLst/>
-          </a:prstGeom>
-          <a:noFill/>
-          <a:ln cap="flat" cmpd="sng" w="19050">
-            <a:solidFill>
-              <a:srgbClr val="FAF4E8"/>
-            </a:solidFill>
-            <a:prstDash val="solid"/>
-            <a:round/>
-            <a:headEnd len="sm" w="sm" type="none"/>
-            <a:tailEnd len="sm" w="sm" type="none"/>
-          </a:ln>
-        </p:spPr>
-      </p:cxnSp>
+          <p:cNvSpPr/>
+          <p:nvPr/>
+        </p:nvSpPr>
+        <p:spPr>
+          <a:xfrm>
+            <a:off x="8430768" y="3812667"/>
+            <a:ext cx="2926080" cy="19050"/>
+          </a:xfrm>
+          <a:prstGeom prst="rect">
+            <a:avLst/>
+          </a:prstGeom>
+          <a:solidFill>
+            <a:srgbClr val="FAF4E8"/>
+          </a:solidFill>
+          <a:ln>
+            <a:noFill/>
+          </a:ln>
+        </p:spPr>
+        <p:txBody>
+          <a:bodyPr/>
+          <a:lstStyle/>
+          <a:p/>
+        </p:txBody>
+      </p:sp>
       <p:sp>
         <p:nvSpPr>
           <p:cNvPr id="44" name="Google Shape;44;p1"/>
@@ -4809,32 +4819,33 @@
           </a:p>
         </p:txBody>
       </p:sp>
-      <p:cxnSp>
-        <p:nvCxnSpPr>
+      <p:sp>
+        <p:nvSpPr>
           <p:cNvPr id="49" name="Google Shape;49;p1"/>
-          <p:cNvCxnSpPr/>
-          <p:nvPr/>
-        </p:nvCxnSpPr>
-        <p:spPr>
-          <a:xfrm>
-            <a:off x="8430768" y="5541264"/>
-            <a:ext cx="2926080" cy="1"/>
-          </a:xfrm>
-          <a:prstGeom prst="straightConnector1">
-            <a:avLst/>
-          </a:prstGeom>
-          <a:noFill/>
-          <a:ln cap="flat" cmpd="sng" w="19050">
-            <a:solidFill>
-              <a:srgbClr val="FAF4E8"/>
-            </a:solidFill>
-            <a:prstDash val="solid"/>
-            <a:round/>
-            <a:headEnd len="sm" w="sm" type="none"/>
-            <a:tailEnd len="sm" w="sm" type="none"/>
-          </a:ln>
-        </p:spPr>
-      </p:cxnSp>
+          <p:cNvSpPr/>
+          <p:nvPr/>
+        </p:nvSpPr>
+        <p:spPr>
+          <a:xfrm>
+            <a:off x="8430768" y="5531739"/>
+            <a:ext cx="2926080" cy="19050"/>
+          </a:xfrm>
+          <a:prstGeom prst="rect">
+            <a:avLst/>
+          </a:prstGeom>
+          <a:solidFill>
+            <a:srgbClr val="FAF4E8"/>
+          </a:solidFill>
+          <a:ln>
+            <a:noFill/>
+          </a:ln>
+        </p:spPr>
+        <p:txBody>
+          <a:bodyPr/>
+          <a:lstStyle/>
+          <a:p/>
+        </p:txBody>
+      </p:sp>
       <p:sp>
         <p:nvSpPr>
           <p:cNvPr id="50" name="Google Shape;50;p1"/>
@@ -4952,32 +4963,33 @@
           </a:p>
         </p:txBody>
       </p:sp>
-      <p:cxnSp>
-        <p:nvCxnSpPr>
+      <p:sp>
+        <p:nvSpPr>
           <p:cNvPr id="52" name="Google Shape;52;p1"/>
-          <p:cNvCxnSpPr/>
-          <p:nvPr/>
-        </p:nvCxnSpPr>
-        <p:spPr>
-          <a:xfrm>
-            <a:off x="548640" y="6455664"/>
-            <a:ext cx="11094415" cy="1"/>
-          </a:xfrm>
-          <a:prstGeom prst="straightConnector1">
-            <a:avLst/>
-          </a:prstGeom>
-          <a:noFill/>
-          <a:ln cap="flat" cmpd="sng" w="28575">
-            <a:solidFill>
-              <a:srgbClr val="111111"/>
-            </a:solidFill>
-            <a:prstDash val="solid"/>
-            <a:round/>
-            <a:headEnd len="sm" w="sm" type="none"/>
-            <a:tailEnd len="sm" w="sm" type="none"/>
-          </a:ln>
-        </p:spPr>
-      </p:cxnSp>
+          <p:cNvSpPr/>
+          <p:nvPr/>
+        </p:nvSpPr>
+        <p:spPr>
+          <a:xfrm>
+            <a:off x="548640" y="6441377"/>
+            <a:ext cx="11094415" cy="28575"/>
+          </a:xfrm>
+          <a:prstGeom prst="rect">
+            <a:avLst/>
+          </a:prstGeom>
+          <a:solidFill>
+            <a:srgbClr val="111111"/>
+          </a:solidFill>
+          <a:ln>
+            <a:noFill/>
+          </a:ln>
+        </p:spPr>
+        <p:txBody>
+          <a:bodyPr/>
+          <a:lstStyle/>
+          <a:p/>
+        </p:txBody>
+      </p:sp>
       <p:sp>
         <p:nvSpPr>
           <p:cNvPr id="53" name="Google Shape;53;p1"/>
@@ -5237,58 +5249,60 @@
           </a:p>
         </p:txBody>
       </p:sp>
-      <p:cxnSp>
-        <p:nvCxnSpPr>
+      <p:sp>
+        <p:nvSpPr>
           <p:cNvPr id="62" name="Google Shape;62;p2"/>
-          <p:cNvCxnSpPr/>
-          <p:nvPr/>
-        </p:nvCxnSpPr>
-        <p:spPr>
-          <a:xfrm>
-            <a:off x="694944" y="274320"/>
-            <a:ext cx="1" cy="292608"/>
-          </a:xfrm>
-          <a:prstGeom prst="straightConnector1">
-            <a:avLst/>
-          </a:prstGeom>
-          <a:noFill/>
-          <a:ln cap="flat" cmpd="sng" w="25400">
-            <a:solidFill>
-              <a:srgbClr val="111111"/>
-            </a:solidFill>
-            <a:prstDash val="solid"/>
-            <a:round/>
-            <a:headEnd len="sm" w="sm" type="none"/>
-            <a:tailEnd len="sm" w="sm" type="none"/>
-          </a:ln>
-        </p:spPr>
-      </p:cxnSp>
-      <p:cxnSp>
-        <p:nvCxnSpPr>
+          <p:cNvSpPr/>
+          <p:nvPr/>
+        </p:nvSpPr>
+        <p:spPr>
+          <a:xfrm>
+            <a:off x="682244" y="274320"/>
+            <a:ext cx="25400" cy="292608"/>
+          </a:xfrm>
+          <a:prstGeom prst="rect">
+            <a:avLst/>
+          </a:prstGeom>
+          <a:solidFill>
+            <a:srgbClr val="111111"/>
+          </a:solidFill>
+          <a:ln>
+            <a:noFill/>
+          </a:ln>
+        </p:spPr>
+        <p:txBody>
+          <a:bodyPr/>
+          <a:lstStyle/>
+          <a:p/>
+        </p:txBody>
+      </p:sp>
+      <p:sp>
+        <p:nvSpPr>
           <p:cNvPr id="63" name="Google Shape;63;p2"/>
-          <p:cNvCxnSpPr/>
-          <p:nvPr/>
-        </p:nvCxnSpPr>
-        <p:spPr>
-          <a:xfrm>
-            <a:off x="694944" y="420624"/>
-            <a:ext cx="146304" cy="1"/>
-          </a:xfrm>
-          <a:prstGeom prst="straightConnector1">
-            <a:avLst/>
-          </a:prstGeom>
-          <a:noFill/>
-          <a:ln cap="flat" cmpd="sng" w="25400">
-            <a:solidFill>
-              <a:srgbClr val="111111"/>
-            </a:solidFill>
-            <a:prstDash val="solid"/>
-            <a:round/>
-            <a:headEnd len="sm" w="sm" type="none"/>
-            <a:tailEnd len="sm" w="sm" type="none"/>
-          </a:ln>
-        </p:spPr>
-      </p:cxnSp>
+          <p:cNvSpPr/>
+          <p:nvPr/>
+        </p:nvSpPr>
+        <p:spPr>
+          <a:xfrm>
+            <a:off x="694944" y="407924"/>
+            <a:ext cx="146304" cy="25400"/>
+          </a:xfrm>
+          <a:prstGeom prst="rect">
+            <a:avLst/>
+          </a:prstGeom>
+          <a:solidFill>
+            <a:srgbClr val="111111"/>
+          </a:solidFill>
+          <a:ln>
+            <a:noFill/>
+          </a:ln>
+        </p:spPr>
+        <p:txBody>
+          <a:bodyPr/>
+          <a:lstStyle/>
+          <a:p/>
+        </p:txBody>
+      </p:sp>
       <p:sp>
         <p:nvSpPr>
           <p:cNvPr id="64" name="Google Shape;64;p2"/>
@@ -5489,32 +5503,33 @@
           </a:p>
         </p:txBody>
       </p:sp>
-      <p:cxnSp>
-        <p:nvCxnSpPr>
+      <p:sp>
+        <p:nvSpPr>
           <p:cNvPr id="67" name="Google Shape;67;p2"/>
-          <p:cNvCxnSpPr/>
-          <p:nvPr/>
-        </p:nvCxnSpPr>
-        <p:spPr>
-          <a:xfrm>
-            <a:off x="548640" y="6455664"/>
-            <a:ext cx="11094415" cy="1"/>
-          </a:xfrm>
-          <a:prstGeom prst="straightConnector1">
-            <a:avLst/>
-          </a:prstGeom>
-          <a:noFill/>
-          <a:ln cap="flat" cmpd="sng" w="28575">
-            <a:solidFill>
-              <a:srgbClr val="111111"/>
-            </a:solidFill>
-            <a:prstDash val="solid"/>
-            <a:round/>
-            <a:headEnd len="sm" w="sm" type="none"/>
-            <a:tailEnd len="sm" w="sm" type="none"/>
-          </a:ln>
-        </p:spPr>
-      </p:cxnSp>
+          <p:cNvSpPr/>
+          <p:nvPr/>
+        </p:nvSpPr>
+        <p:spPr>
+          <a:xfrm>
+            <a:off x="548640" y="6441377"/>
+            <a:ext cx="11094415" cy="28575"/>
+          </a:xfrm>
+          <a:prstGeom prst="rect">
+            <a:avLst/>
+          </a:prstGeom>
+          <a:solidFill>
+            <a:srgbClr val="111111"/>
+          </a:solidFill>
+          <a:ln>
+            <a:noFill/>
+          </a:ln>
+        </p:spPr>
+        <p:txBody>
+          <a:bodyPr/>
+          <a:lstStyle/>
+          <a:p/>
+        </p:txBody>
+      </p:sp>
       <p:sp>
         <p:nvSpPr>
           <p:cNvPr id="68" name="Google Shape;68;p2"/>
@@ -7026,58 +7041,60 @@
           </a:p>
         </p:txBody>
       </p:sp>
-      <p:cxnSp>
-        <p:nvCxnSpPr>
+      <p:sp>
+        <p:nvSpPr>
           <p:cNvPr id="98" name="Google Shape;98;p3"/>
-          <p:cNvCxnSpPr/>
-          <p:nvPr/>
-        </p:nvCxnSpPr>
-        <p:spPr>
-          <a:xfrm>
-            <a:off x="694944" y="274320"/>
-            <a:ext cx="1" cy="292608"/>
-          </a:xfrm>
-          <a:prstGeom prst="straightConnector1">
-            <a:avLst/>
-          </a:prstGeom>
-          <a:noFill/>
-          <a:ln cap="flat" cmpd="sng" w="25400">
-            <a:solidFill>
-              <a:srgbClr val="111111"/>
-            </a:solidFill>
-            <a:prstDash val="solid"/>
-            <a:round/>
-            <a:headEnd len="sm" w="sm" type="none"/>
-            <a:tailEnd len="sm" w="sm" type="none"/>
-          </a:ln>
-        </p:spPr>
-      </p:cxnSp>
-      <p:cxnSp>
-        <p:nvCxnSpPr>
+          <p:cNvSpPr/>
+          <p:nvPr/>
+        </p:nvSpPr>
+        <p:spPr>
+          <a:xfrm>
+            <a:off x="682244" y="274320"/>
+            <a:ext cx="25400" cy="292608"/>
+          </a:xfrm>
+          <a:prstGeom prst="rect">
+            <a:avLst/>
+          </a:prstGeom>
+          <a:solidFill>
+            <a:srgbClr val="111111"/>
+          </a:solidFill>
+          <a:ln>
+            <a:noFill/>
+          </a:ln>
+        </p:spPr>
+        <p:txBody>
+          <a:bodyPr/>
+          <a:lstStyle/>
+          <a:p/>
+        </p:txBody>
+      </p:sp>
+      <p:sp>
+        <p:nvSpPr>
           <p:cNvPr id="99" name="Google Shape;99;p3"/>
-          <p:cNvCxnSpPr/>
-          <p:nvPr/>
-        </p:nvCxnSpPr>
-        <p:spPr>
-          <a:xfrm>
-            <a:off x="694944" y="420624"/>
-            <a:ext cx="146304" cy="1"/>
-          </a:xfrm>
-          <a:prstGeom prst="straightConnector1">
-            <a:avLst/>
-          </a:prstGeom>
-          <a:noFill/>
-          <a:ln cap="flat" cmpd="sng" w="25400">
-            <a:solidFill>
-              <a:srgbClr val="111111"/>
-            </a:solidFill>
-            <a:prstDash val="solid"/>
-            <a:round/>
-            <a:headEnd len="sm" w="sm" type="none"/>
-            <a:tailEnd len="sm" w="sm" type="none"/>
-          </a:ln>
-        </p:spPr>
-      </p:cxnSp>
+          <p:cNvSpPr/>
+          <p:nvPr/>
+        </p:nvSpPr>
+        <p:spPr>
+          <a:xfrm>
+            <a:off x="694944" y="407924"/>
+            <a:ext cx="146304" cy="25400"/>
+          </a:xfrm>
+          <a:prstGeom prst="rect">
+            <a:avLst/>
+          </a:prstGeom>
+          <a:solidFill>
+            <a:srgbClr val="111111"/>
+          </a:solidFill>
+          <a:ln>
+            <a:noFill/>
+          </a:ln>
+        </p:spPr>
+        <p:txBody>
+          <a:bodyPr/>
+          <a:lstStyle/>
+          <a:p/>
+        </p:txBody>
+      </p:sp>
       <p:sp>
         <p:nvSpPr>
           <p:cNvPr id="100" name="Google Shape;100;p3"/>
@@ -7258,32 +7275,33 @@
           </a:p>
         </p:txBody>
       </p:sp>
-      <p:cxnSp>
-        <p:nvCxnSpPr>
+      <p:sp>
+        <p:nvSpPr>
           <p:cNvPr id="103" name="Google Shape;103;p3"/>
-          <p:cNvCxnSpPr/>
-          <p:nvPr/>
-        </p:nvCxnSpPr>
-        <p:spPr>
-          <a:xfrm>
-            <a:off x="548640" y="6455664"/>
-            <a:ext cx="11094415" cy="1"/>
-          </a:xfrm>
-          <a:prstGeom prst="straightConnector1">
-            <a:avLst/>
-          </a:prstGeom>
-          <a:noFill/>
-          <a:ln cap="flat" cmpd="sng" w="28575">
-            <a:solidFill>
-              <a:srgbClr val="111111"/>
-            </a:solidFill>
-            <a:prstDash val="solid"/>
-            <a:round/>
-            <a:headEnd len="sm" w="sm" type="none"/>
-            <a:tailEnd len="sm" w="sm" type="none"/>
-          </a:ln>
-        </p:spPr>
-      </p:cxnSp>
+          <p:cNvSpPr/>
+          <p:nvPr/>
+        </p:nvSpPr>
+        <p:spPr>
+          <a:xfrm>
+            <a:off x="548640" y="6441377"/>
+            <a:ext cx="11094415" cy="28575"/>
+          </a:xfrm>
+          <a:prstGeom prst="rect">
+            <a:avLst/>
+          </a:prstGeom>
+          <a:solidFill>
+            <a:srgbClr val="111111"/>
+          </a:solidFill>
+          <a:ln>
+            <a:noFill/>
+          </a:ln>
+        </p:spPr>
+        <p:txBody>
+          <a:bodyPr/>
+          <a:lstStyle/>
+          <a:p/>
+        </p:txBody>
+      </p:sp>
       <p:sp>
         <p:nvSpPr>
           <p:cNvPr id="104" name="Google Shape;104;p3"/>
@@ -7719,32 +7737,33 @@
           </a:p>
         </p:txBody>
       </p:sp>
-      <p:cxnSp>
-        <p:nvCxnSpPr>
+      <p:sp>
+        <p:nvSpPr>
           <p:cNvPr id="111" name="Google Shape;111;p3"/>
-          <p:cNvCxnSpPr/>
-          <p:nvPr/>
-        </p:nvCxnSpPr>
-        <p:spPr>
-          <a:xfrm>
-            <a:off x="868680" y="4069080"/>
-            <a:ext cx="3291840" cy="1"/>
-          </a:xfrm>
-          <a:prstGeom prst="straightConnector1">
-            <a:avLst/>
-          </a:prstGeom>
-          <a:noFill/>
-          <a:ln cap="flat" cmpd="sng" w="19050">
-            <a:solidFill>
-              <a:srgbClr val="111111"/>
-            </a:solidFill>
-            <a:prstDash val="solid"/>
-            <a:round/>
-            <a:headEnd len="sm" w="sm" type="none"/>
-            <a:tailEnd len="sm" w="sm" type="none"/>
-          </a:ln>
-        </p:spPr>
-      </p:cxnSp>
+          <p:cNvSpPr/>
+          <p:nvPr/>
+        </p:nvSpPr>
+        <p:spPr>
+          <a:xfrm>
+            <a:off x="868680" y="4059555"/>
+            <a:ext cx="3291840" cy="19050"/>
+          </a:xfrm>
+          <a:prstGeom prst="rect">
+            <a:avLst/>
+          </a:prstGeom>
+          <a:solidFill>
+            <a:srgbClr val="111111"/>
+          </a:solidFill>
+          <a:ln>
+            <a:noFill/>
+          </a:ln>
+        </p:spPr>
+        <p:txBody>
+          <a:bodyPr/>
+          <a:lstStyle/>
+          <a:p/>
+        </p:txBody>
+      </p:sp>
       <p:sp>
         <p:nvSpPr>
           <p:cNvPr id="112" name="Google Shape;112;p3"/>
@@ -7858,58 +7877,60 @@
           </a:p>
         </p:txBody>
       </p:sp>
-      <p:cxnSp>
-        <p:nvCxnSpPr>
+      <p:sp>
+        <p:nvSpPr>
           <p:cNvPr id="114" name="Google Shape;114;p3"/>
-          <p:cNvCxnSpPr/>
-          <p:nvPr/>
-        </p:nvCxnSpPr>
-        <p:spPr>
-          <a:xfrm>
-            <a:off x="1060704" y="5532120"/>
-            <a:ext cx="1" cy="384048"/>
-          </a:xfrm>
-          <a:prstGeom prst="straightConnector1">
-            <a:avLst/>
-          </a:prstGeom>
-          <a:noFill/>
-          <a:ln cap="flat" cmpd="sng" w="25400">
-            <a:solidFill>
-              <a:srgbClr val="111111"/>
-            </a:solidFill>
-            <a:prstDash val="solid"/>
-            <a:round/>
-            <a:headEnd len="sm" w="sm" type="none"/>
-            <a:tailEnd len="sm" w="sm" type="none"/>
-          </a:ln>
-        </p:spPr>
-      </p:cxnSp>
-      <p:cxnSp>
-        <p:nvCxnSpPr>
+          <p:cNvSpPr/>
+          <p:nvPr/>
+        </p:nvSpPr>
+        <p:spPr>
+          <a:xfrm>
+            <a:off x="1048004" y="5532120"/>
+            <a:ext cx="25400" cy="384048"/>
+          </a:xfrm>
+          <a:prstGeom prst="rect">
+            <a:avLst/>
+          </a:prstGeom>
+          <a:solidFill>
+            <a:srgbClr val="111111"/>
+          </a:solidFill>
+          <a:ln>
+            <a:noFill/>
+          </a:ln>
+        </p:spPr>
+        <p:txBody>
+          <a:bodyPr/>
+          <a:lstStyle/>
+          <a:p/>
+        </p:txBody>
+      </p:sp>
+      <p:sp>
+        <p:nvSpPr>
           <p:cNvPr id="115" name="Google Shape;115;p3"/>
-          <p:cNvCxnSpPr/>
-          <p:nvPr/>
-        </p:nvCxnSpPr>
-        <p:spPr>
-          <a:xfrm>
-            <a:off x="1060704" y="5724144"/>
-            <a:ext cx="192024" cy="1"/>
-          </a:xfrm>
-          <a:prstGeom prst="straightConnector1">
-            <a:avLst/>
-          </a:prstGeom>
-          <a:noFill/>
-          <a:ln cap="flat" cmpd="sng" w="25400">
-            <a:solidFill>
-              <a:srgbClr val="111111"/>
-            </a:solidFill>
-            <a:prstDash val="solid"/>
-            <a:round/>
-            <a:headEnd len="sm" w="sm" type="none"/>
-            <a:tailEnd len="sm" w="sm" type="none"/>
-          </a:ln>
-        </p:spPr>
-      </p:cxnSp>
+          <p:cNvSpPr/>
+          <p:nvPr/>
+        </p:nvSpPr>
+        <p:spPr>
+          <a:xfrm>
+            <a:off x="1060704" y="5711444"/>
+            <a:ext cx="192024" cy="25400"/>
+          </a:xfrm>
+          <a:prstGeom prst="rect">
+            <a:avLst/>
+          </a:prstGeom>
+          <a:solidFill>
+            <a:srgbClr val="111111"/>
+          </a:solidFill>
+          <a:ln>
+            <a:noFill/>
+          </a:ln>
+        </p:spPr>
+        <p:txBody>
+          <a:bodyPr/>
+          <a:lstStyle/>
+          <a:p/>
+        </p:txBody>
+      </p:sp>
       <p:sp>
         <p:nvSpPr>
           <p:cNvPr id="116" name="Google Shape;116;p3"/>
@@ -8865,58 +8886,60 @@
           </a:p>
         </p:txBody>
       </p:sp>
-      <p:cxnSp>
-        <p:nvCxnSpPr>
+      <p:sp>
+        <p:nvSpPr>
           <p:cNvPr id="137" name="Google Shape;137;p4"/>
-          <p:cNvCxnSpPr/>
-          <p:nvPr/>
-        </p:nvCxnSpPr>
-        <p:spPr>
-          <a:xfrm>
-            <a:off x="694944" y="274320"/>
-            <a:ext cx="1" cy="292608"/>
-          </a:xfrm>
-          <a:prstGeom prst="straightConnector1">
-            <a:avLst/>
-          </a:prstGeom>
-          <a:noFill/>
-          <a:ln cap="flat" cmpd="sng" w="25400">
-            <a:solidFill>
-              <a:srgbClr val="111111"/>
-            </a:solidFill>
-            <a:prstDash val="solid"/>
-            <a:round/>
-            <a:headEnd len="sm" w="sm" type="none"/>
-            <a:tailEnd len="sm" w="sm" type="none"/>
-          </a:ln>
-        </p:spPr>
-      </p:cxnSp>
-      <p:cxnSp>
-        <p:nvCxnSpPr>
+          <p:cNvSpPr/>
+          <p:nvPr/>
+        </p:nvSpPr>
+        <p:spPr>
+          <a:xfrm>
+            <a:off x="682244" y="274320"/>
+            <a:ext cx="25400" cy="292608"/>
+          </a:xfrm>
+          <a:prstGeom prst="rect">
+            <a:avLst/>
+          </a:prstGeom>
+          <a:solidFill>
+            <a:srgbClr val="111111"/>
+          </a:solidFill>
+          <a:ln>
+            <a:noFill/>
+          </a:ln>
+        </p:spPr>
+        <p:txBody>
+          <a:bodyPr/>
+          <a:lstStyle/>
+          <a:p/>
+        </p:txBody>
+      </p:sp>
+      <p:sp>
+        <p:nvSpPr>
           <p:cNvPr id="138" name="Google Shape;138;p4"/>
-          <p:cNvCxnSpPr/>
-          <p:nvPr/>
-        </p:nvCxnSpPr>
-        <p:spPr>
-          <a:xfrm>
-            <a:off x="694944" y="420624"/>
-            <a:ext cx="146304" cy="1"/>
-          </a:xfrm>
-          <a:prstGeom prst="straightConnector1">
-            <a:avLst/>
-          </a:prstGeom>
-          <a:noFill/>
-          <a:ln cap="flat" cmpd="sng" w="25400">
-            <a:solidFill>
-              <a:srgbClr val="111111"/>
-            </a:solidFill>
-            <a:prstDash val="solid"/>
-            <a:round/>
-            <a:headEnd len="sm" w="sm" type="none"/>
-            <a:tailEnd len="sm" w="sm" type="none"/>
-          </a:ln>
-        </p:spPr>
-      </p:cxnSp>
+          <p:cNvSpPr/>
+          <p:nvPr/>
+        </p:nvSpPr>
+        <p:spPr>
+          <a:xfrm>
+            <a:off x="694944" y="407924"/>
+            <a:ext cx="146304" cy="25400"/>
+          </a:xfrm>
+          <a:prstGeom prst="rect">
+            <a:avLst/>
+          </a:prstGeom>
+          <a:solidFill>
+            <a:srgbClr val="111111"/>
+          </a:solidFill>
+          <a:ln>
+            <a:noFill/>
+          </a:ln>
+        </p:spPr>
+        <p:txBody>
+          <a:bodyPr/>
+          <a:lstStyle/>
+          <a:p/>
+        </p:txBody>
+      </p:sp>
       <p:sp>
         <p:nvSpPr>
           <p:cNvPr id="139" name="Google Shape;139;p4"/>
@@ -9097,32 +9120,33 @@
           </a:p>
         </p:txBody>
       </p:sp>
-      <p:cxnSp>
-        <p:nvCxnSpPr>
+      <p:sp>
+        <p:nvSpPr>
           <p:cNvPr id="142" name="Google Shape;142;p4"/>
-          <p:cNvCxnSpPr/>
-          <p:nvPr/>
-        </p:nvCxnSpPr>
-        <p:spPr>
-          <a:xfrm>
-            <a:off x="548640" y="6455664"/>
-            <a:ext cx="11094415" cy="1"/>
-          </a:xfrm>
-          <a:prstGeom prst="straightConnector1">
-            <a:avLst/>
-          </a:prstGeom>
-          <a:noFill/>
-          <a:ln cap="flat" cmpd="sng" w="28575">
-            <a:solidFill>
-              <a:srgbClr val="111111"/>
-            </a:solidFill>
-            <a:prstDash val="solid"/>
-            <a:round/>
-            <a:headEnd len="sm" w="sm" type="none"/>
-            <a:tailEnd len="sm" w="sm" type="none"/>
-          </a:ln>
-        </p:spPr>
-      </p:cxnSp>
+          <p:cNvSpPr/>
+          <p:nvPr/>
+        </p:nvSpPr>
+        <p:spPr>
+          <a:xfrm>
+            <a:off x="548640" y="6441377"/>
+            <a:ext cx="11094415" cy="28575"/>
+          </a:xfrm>
+          <a:prstGeom prst="rect">
+            <a:avLst/>
+          </a:prstGeom>
+          <a:solidFill>
+            <a:srgbClr val="111111"/>
+          </a:solidFill>
+          <a:ln>
+            <a:noFill/>
+          </a:ln>
+        </p:spPr>
+        <p:txBody>
+          <a:bodyPr/>
+          <a:lstStyle/>
+          <a:p/>
+        </p:txBody>
+      </p:sp>
       <p:sp>
         <p:nvSpPr>
           <p:cNvPr id="143" name="Google Shape;143;p4"/>
@@ -9609,32 +9633,33 @@
           </a:p>
         </p:txBody>
       </p:sp>
-      <p:cxnSp>
-        <p:nvCxnSpPr>
+      <p:sp>
+        <p:nvSpPr>
           <p:cNvPr id="151" name="Google Shape;151;p4"/>
-          <p:cNvCxnSpPr/>
-          <p:nvPr/>
-        </p:nvCxnSpPr>
-        <p:spPr>
-          <a:xfrm>
-            <a:off x="2848356" y="2825496"/>
-            <a:ext cx="237744" cy="1"/>
-          </a:xfrm>
-          <a:prstGeom prst="straightConnector1">
-            <a:avLst/>
-          </a:prstGeom>
-          <a:noFill/>
-          <a:ln cap="flat" cmpd="sng" w="31750">
-            <a:solidFill>
-              <a:srgbClr val="111111"/>
-            </a:solidFill>
-            <a:prstDash val="solid"/>
-            <a:round/>
-            <a:headEnd len="sm" w="sm" type="none"/>
-            <a:tailEnd len="med" w="med" type="triangle"/>
-          </a:ln>
-        </p:spPr>
-      </p:cxnSp>
+          <p:cNvSpPr/>
+          <p:nvPr/>
+        </p:nvSpPr>
+        <p:spPr>
+          <a:xfrm>
+            <a:off x="2848356" y="2809621"/>
+            <a:ext cx="237744" cy="31750"/>
+          </a:xfrm>
+          <a:prstGeom prst="rect">
+            <a:avLst/>
+          </a:prstGeom>
+          <a:solidFill>
+            <a:srgbClr val="111111"/>
+          </a:solidFill>
+          <a:ln>
+            <a:noFill/>
+          </a:ln>
+        </p:spPr>
+        <p:txBody>
+          <a:bodyPr/>
+          <a:lstStyle/>
+          <a:p/>
+        </p:txBody>
+      </p:sp>
       <p:sp>
         <p:nvSpPr>
           <p:cNvPr id="152" name="Google Shape;152;p4"/>
@@ -9752,32 +9777,33 @@
           </a:p>
         </p:txBody>
       </p:sp>
-      <p:cxnSp>
-        <p:nvCxnSpPr>
+      <p:sp>
+        <p:nvSpPr>
           <p:cNvPr id="154" name="Google Shape;154;p4"/>
-          <p:cNvCxnSpPr/>
-          <p:nvPr/>
-        </p:nvCxnSpPr>
-        <p:spPr>
-          <a:xfrm>
-            <a:off x="4613148" y="2825496"/>
-            <a:ext cx="237744" cy="1"/>
-          </a:xfrm>
-          <a:prstGeom prst="straightConnector1">
-            <a:avLst/>
-          </a:prstGeom>
-          <a:noFill/>
-          <a:ln cap="flat" cmpd="sng" w="31750">
-            <a:solidFill>
-              <a:srgbClr val="111111"/>
-            </a:solidFill>
-            <a:prstDash val="solid"/>
-            <a:round/>
-            <a:headEnd len="sm" w="sm" type="none"/>
-            <a:tailEnd len="med" w="med" type="triangle"/>
-          </a:ln>
-        </p:spPr>
-      </p:cxnSp>
+          <p:cNvSpPr/>
+          <p:nvPr/>
+        </p:nvSpPr>
+        <p:spPr>
+          <a:xfrm>
+            <a:off x="4613148" y="2809621"/>
+            <a:ext cx="237744" cy="31750"/>
+          </a:xfrm>
+          <a:prstGeom prst="rect">
+            <a:avLst/>
+          </a:prstGeom>
+          <a:solidFill>
+            <a:srgbClr val="111111"/>
+          </a:solidFill>
+          <a:ln>
+            <a:noFill/>
+          </a:ln>
+        </p:spPr>
+        <p:txBody>
+          <a:bodyPr/>
+          <a:lstStyle/>
+          <a:p/>
+        </p:txBody>
+      </p:sp>
       <p:sp>
         <p:nvSpPr>
           <p:cNvPr id="155" name="Google Shape;155;p4"/>
@@ -9895,32 +9921,33 @@
           </a:p>
         </p:txBody>
       </p:sp>
-      <p:cxnSp>
-        <p:nvCxnSpPr>
+      <p:sp>
+        <p:nvSpPr>
           <p:cNvPr id="157" name="Google Shape;157;p4"/>
-          <p:cNvCxnSpPr/>
-          <p:nvPr/>
-        </p:nvCxnSpPr>
-        <p:spPr>
-          <a:xfrm>
-            <a:off x="6743700" y="2825496"/>
-            <a:ext cx="237744" cy="1"/>
-          </a:xfrm>
-          <a:prstGeom prst="straightConnector1">
-            <a:avLst/>
-          </a:prstGeom>
-          <a:noFill/>
-          <a:ln cap="flat" cmpd="sng" w="31750">
-            <a:solidFill>
-              <a:srgbClr val="111111"/>
-            </a:solidFill>
-            <a:prstDash val="solid"/>
-            <a:round/>
-            <a:headEnd len="sm" w="sm" type="none"/>
-            <a:tailEnd len="med" w="med" type="triangle"/>
-          </a:ln>
-        </p:spPr>
-      </p:cxnSp>
+          <p:cNvSpPr/>
+          <p:nvPr/>
+        </p:nvSpPr>
+        <p:spPr>
+          <a:xfrm>
+            <a:off x="6743700" y="2809621"/>
+            <a:ext cx="237744" cy="31750"/>
+          </a:xfrm>
+          <a:prstGeom prst="rect">
+            <a:avLst/>
+          </a:prstGeom>
+          <a:solidFill>
+            <a:srgbClr val="111111"/>
+          </a:solidFill>
+          <a:ln>
+            <a:noFill/>
+          </a:ln>
+        </p:spPr>
+        <p:txBody>
+          <a:bodyPr/>
+          <a:lstStyle/>
+          <a:p/>
+        </p:txBody>
+      </p:sp>
       <p:sp>
         <p:nvSpPr>
           <p:cNvPr id="158" name="Google Shape;158;p4"/>
@@ -10038,32 +10065,33 @@
           </a:p>
         </p:txBody>
       </p:sp>
-      <p:cxnSp>
-        <p:nvCxnSpPr>
+      <p:sp>
+        <p:nvSpPr>
           <p:cNvPr id="160" name="Google Shape;160;p4"/>
-          <p:cNvCxnSpPr/>
-          <p:nvPr/>
-        </p:nvCxnSpPr>
-        <p:spPr>
-          <a:xfrm>
-            <a:off x="9422892" y="2825496"/>
-            <a:ext cx="237744" cy="1"/>
-          </a:xfrm>
-          <a:prstGeom prst="straightConnector1">
-            <a:avLst/>
-          </a:prstGeom>
-          <a:noFill/>
-          <a:ln cap="flat" cmpd="sng" w="31750">
-            <a:solidFill>
-              <a:srgbClr val="111111"/>
-            </a:solidFill>
-            <a:prstDash val="solid"/>
-            <a:round/>
-            <a:headEnd len="sm" w="sm" type="none"/>
-            <a:tailEnd len="med" w="med" type="triangle"/>
-          </a:ln>
-        </p:spPr>
-      </p:cxnSp>
+          <p:cNvSpPr/>
+          <p:nvPr/>
+        </p:nvSpPr>
+        <p:spPr>
+          <a:xfrm>
+            <a:off x="9422892" y="2809621"/>
+            <a:ext cx="237744" cy="31750"/>
+          </a:xfrm>
+          <a:prstGeom prst="rect">
+            <a:avLst/>
+          </a:prstGeom>
+          <a:solidFill>
+            <a:srgbClr val="111111"/>
+          </a:solidFill>
+          <a:ln>
+            <a:noFill/>
+          </a:ln>
+        </p:spPr>
+        <p:txBody>
+          <a:bodyPr/>
+          <a:lstStyle/>
+          <a:p/>
+        </p:txBody>
+      </p:sp>
       <p:sp>
         <p:nvSpPr>
           <p:cNvPr id="161" name="Google Shape;161;p4"/>
@@ -11208,58 +11236,60 @@
           </a:p>
         </p:txBody>
       </p:sp>
-      <p:cxnSp>
-        <p:nvCxnSpPr>
+      <p:sp>
+        <p:nvSpPr>
           <p:cNvPr id="185" name="Google Shape;185;p5"/>
-          <p:cNvCxnSpPr/>
-          <p:nvPr/>
-        </p:nvCxnSpPr>
-        <p:spPr>
-          <a:xfrm>
-            <a:off x="694944" y="274320"/>
-            <a:ext cx="1" cy="292608"/>
-          </a:xfrm>
-          <a:prstGeom prst="straightConnector1">
-            <a:avLst/>
-          </a:prstGeom>
-          <a:noFill/>
-          <a:ln cap="flat" cmpd="sng" w="25400">
-            <a:solidFill>
-              <a:srgbClr val="111111"/>
-            </a:solidFill>
-            <a:prstDash val="solid"/>
-            <a:round/>
-            <a:headEnd len="sm" w="sm" type="none"/>
-            <a:tailEnd len="sm" w="sm" type="none"/>
-          </a:ln>
-        </p:spPr>
-      </p:cxnSp>
-      <p:cxnSp>
-        <p:nvCxnSpPr>
+          <p:cNvSpPr/>
+          <p:nvPr/>
+        </p:nvSpPr>
+        <p:spPr>
+          <a:xfrm>
+            <a:off x="682244" y="274320"/>
+            <a:ext cx="25400" cy="292608"/>
+          </a:xfrm>
+          <a:prstGeom prst="rect">
+            <a:avLst/>
+          </a:prstGeom>
+          <a:solidFill>
+            <a:srgbClr val="111111"/>
+          </a:solidFill>
+          <a:ln>
+            <a:noFill/>
+          </a:ln>
+        </p:spPr>
+        <p:txBody>
+          <a:bodyPr/>
+          <a:lstStyle/>
+          <a:p/>
+        </p:txBody>
+      </p:sp>
+      <p:sp>
+        <p:nvSpPr>
           <p:cNvPr id="186" name="Google Shape;186;p5"/>
-          <p:cNvCxnSpPr/>
-          <p:nvPr/>
-        </p:nvCxnSpPr>
-        <p:spPr>
-          <a:xfrm>
-            <a:off x="694944" y="420624"/>
-            <a:ext cx="146304" cy="1"/>
-          </a:xfrm>
-          <a:prstGeom prst="straightConnector1">
-            <a:avLst/>
-          </a:prstGeom>
-          <a:noFill/>
-          <a:ln cap="flat" cmpd="sng" w="25400">
-            <a:solidFill>
-              <a:srgbClr val="111111"/>
-            </a:solidFill>
-            <a:prstDash val="solid"/>
-            <a:round/>
-            <a:headEnd len="sm" w="sm" type="none"/>
-            <a:tailEnd len="sm" w="sm" type="none"/>
-          </a:ln>
-        </p:spPr>
-      </p:cxnSp>
+          <p:cNvSpPr/>
+          <p:nvPr/>
+        </p:nvSpPr>
+        <p:spPr>
+          <a:xfrm>
+            <a:off x="694944" y="407924"/>
+            <a:ext cx="146304" cy="25400"/>
+          </a:xfrm>
+          <a:prstGeom prst="rect">
+            <a:avLst/>
+          </a:prstGeom>
+          <a:solidFill>
+            <a:srgbClr val="111111"/>
+          </a:solidFill>
+          <a:ln>
+            <a:noFill/>
+          </a:ln>
+        </p:spPr>
+        <p:txBody>
+          <a:bodyPr/>
+          <a:lstStyle/>
+          <a:p/>
+        </p:txBody>
+      </p:sp>
       <p:sp>
         <p:nvSpPr>
           <p:cNvPr id="187" name="Google Shape;187;p5"/>
@@ -11440,32 +11470,33 @@
           </a:p>
         </p:txBody>
       </p:sp>
-      <p:cxnSp>
-        <p:nvCxnSpPr>
+      <p:sp>
+        <p:nvSpPr>
           <p:cNvPr id="190" name="Google Shape;190;p5"/>
-          <p:cNvCxnSpPr/>
-          <p:nvPr/>
-        </p:nvCxnSpPr>
-        <p:spPr>
-          <a:xfrm>
-            <a:off x="548640" y="6455664"/>
-            <a:ext cx="11094415" cy="1"/>
-          </a:xfrm>
-          <a:prstGeom prst="straightConnector1">
-            <a:avLst/>
-          </a:prstGeom>
-          <a:noFill/>
-          <a:ln cap="flat" cmpd="sng" w="28575">
-            <a:solidFill>
-              <a:srgbClr val="111111"/>
-            </a:solidFill>
-            <a:prstDash val="solid"/>
-            <a:round/>
-            <a:headEnd len="sm" w="sm" type="none"/>
-            <a:tailEnd len="sm" w="sm" type="none"/>
-          </a:ln>
-        </p:spPr>
-      </p:cxnSp>
+          <p:cNvSpPr/>
+          <p:nvPr/>
+        </p:nvSpPr>
+        <p:spPr>
+          <a:xfrm>
+            <a:off x="548640" y="6441377"/>
+            <a:ext cx="11094415" cy="28575"/>
+          </a:xfrm>
+          <a:prstGeom prst="rect">
+            <a:avLst/>
+          </a:prstGeom>
+          <a:solidFill>
+            <a:srgbClr val="111111"/>
+          </a:solidFill>
+          <a:ln>
+            <a:noFill/>
+          </a:ln>
+        </p:spPr>
+        <p:txBody>
+          <a:bodyPr/>
+          <a:lstStyle/>
+          <a:p/>
+        </p:txBody>
+      </p:sp>
       <p:sp>
         <p:nvSpPr>
           <p:cNvPr id="191" name="Google Shape;191;p5"/>
@@ -13061,58 +13092,60 @@
           </a:p>
         </p:txBody>
       </p:sp>
-      <p:cxnSp>
-        <p:nvCxnSpPr>
+      <p:sp>
+        <p:nvSpPr>
           <p:cNvPr id="222" name="Google Shape;222;p6"/>
-          <p:cNvCxnSpPr/>
-          <p:nvPr/>
-        </p:nvCxnSpPr>
-        <p:spPr>
-          <a:xfrm>
-            <a:off x="694944" y="274320"/>
-            <a:ext cx="1" cy="292608"/>
-          </a:xfrm>
-          <a:prstGeom prst="straightConnector1">
-            <a:avLst/>
-          </a:prstGeom>
-          <a:noFill/>
-          <a:ln cap="flat" cmpd="sng" w="25400">
-            <a:solidFill>
-              <a:srgbClr val="FAF4E8"/>
-            </a:solidFill>
-            <a:prstDash val="solid"/>
-            <a:round/>
-            <a:headEnd len="sm" w="sm" type="none"/>
-            <a:tailEnd len="sm" w="sm" type="none"/>
-          </a:ln>
-        </p:spPr>
-      </p:cxnSp>
-      <p:cxnSp>
-        <p:nvCxnSpPr>
+          <p:cNvSpPr/>
+          <p:nvPr/>
+        </p:nvSpPr>
+        <p:spPr>
+          <a:xfrm>
+            <a:off x="682244" y="274320"/>
+            <a:ext cx="25400" cy="292608"/>
+          </a:xfrm>
+          <a:prstGeom prst="rect">
+            <a:avLst/>
+          </a:prstGeom>
+          <a:solidFill>
+            <a:srgbClr val="FAF4E8"/>
+          </a:solidFill>
+          <a:ln>
+            <a:noFill/>
+          </a:ln>
+        </p:spPr>
+        <p:txBody>
+          <a:bodyPr/>
+          <a:lstStyle/>
+          <a:p/>
+        </p:txBody>
+      </p:sp>
+      <p:sp>
+        <p:nvSpPr>
           <p:cNvPr id="223" name="Google Shape;223;p6"/>
-          <p:cNvCxnSpPr/>
-          <p:nvPr/>
-        </p:nvCxnSpPr>
-        <p:spPr>
-          <a:xfrm>
-            <a:off x="694944" y="420624"/>
-            <a:ext cx="146304" cy="1"/>
-          </a:xfrm>
-          <a:prstGeom prst="straightConnector1">
-            <a:avLst/>
-          </a:prstGeom>
-          <a:noFill/>
-          <a:ln cap="flat" cmpd="sng" w="25400">
-            <a:solidFill>
-              <a:srgbClr val="FAF4E8"/>
-            </a:solidFill>
-            <a:prstDash val="solid"/>
-            <a:round/>
-            <a:headEnd len="sm" w="sm" type="none"/>
-            <a:tailEnd len="sm" w="sm" type="none"/>
-          </a:ln>
-        </p:spPr>
-      </p:cxnSp>
+          <p:cNvSpPr/>
+          <p:nvPr/>
+        </p:nvSpPr>
+        <p:spPr>
+          <a:xfrm>
+            <a:off x="694944" y="407924"/>
+            <a:ext cx="146304" cy="25400"/>
+          </a:xfrm>
+          <a:prstGeom prst="rect">
+            <a:avLst/>
+          </a:prstGeom>
+          <a:solidFill>
+            <a:srgbClr val="FAF4E8"/>
+          </a:solidFill>
+          <a:ln>
+            <a:noFill/>
+          </a:ln>
+        </p:spPr>
+        <p:txBody>
+          <a:bodyPr/>
+          <a:lstStyle/>
+          <a:p/>
+        </p:txBody>
+      </p:sp>
       <p:sp>
         <p:nvSpPr>
           <p:cNvPr id="224" name="Google Shape;224;p6"/>
@@ -13293,32 +13326,33 @@
           </a:p>
         </p:txBody>
       </p:sp>
-      <p:cxnSp>
-        <p:nvCxnSpPr>
+      <p:sp>
+        <p:nvSpPr>
           <p:cNvPr id="227" name="Google Shape;227;p6"/>
-          <p:cNvCxnSpPr/>
-          <p:nvPr/>
-        </p:nvCxnSpPr>
-        <p:spPr>
-          <a:xfrm>
-            <a:off x="548640" y="6455664"/>
-            <a:ext cx="11094415" cy="1"/>
-          </a:xfrm>
-          <a:prstGeom prst="straightConnector1">
-            <a:avLst/>
-          </a:prstGeom>
-          <a:noFill/>
-          <a:ln cap="flat" cmpd="sng" w="28575">
-            <a:solidFill>
-              <a:srgbClr val="FAF4E8"/>
-            </a:solidFill>
-            <a:prstDash val="solid"/>
-            <a:round/>
-            <a:headEnd len="sm" w="sm" type="none"/>
-            <a:tailEnd len="sm" w="sm" type="none"/>
-          </a:ln>
-        </p:spPr>
-      </p:cxnSp>
+          <p:cNvSpPr/>
+          <p:nvPr/>
+        </p:nvSpPr>
+        <p:spPr>
+          <a:xfrm>
+            <a:off x="548640" y="6441377"/>
+            <a:ext cx="11094415" cy="28575"/>
+          </a:xfrm>
+          <a:prstGeom prst="rect">
+            <a:avLst/>
+          </a:prstGeom>
+          <a:solidFill>
+            <a:srgbClr val="FAF4E8"/>
+          </a:solidFill>
+          <a:ln>
+            <a:noFill/>
+          </a:ln>
+        </p:spPr>
+        <p:txBody>
+          <a:bodyPr/>
+          <a:lstStyle/>
+          <a:p/>
+        </p:txBody>
+      </p:sp>
       <p:sp>
         <p:nvSpPr>
           <p:cNvPr id="228" name="Google Shape;228;p6"/>
@@ -15124,58 +15158,60 @@
           </a:p>
         </p:txBody>
       </p:sp>
-      <p:cxnSp>
-        <p:nvCxnSpPr>
+      <p:sp>
+        <p:nvSpPr>
           <p:cNvPr id="263" name="Google Shape;263;p7"/>
-          <p:cNvCxnSpPr/>
-          <p:nvPr/>
-        </p:nvCxnSpPr>
-        <p:spPr>
-          <a:xfrm>
-            <a:off x="694944" y="274320"/>
-            <a:ext cx="1" cy="292608"/>
-          </a:xfrm>
-          <a:prstGeom prst="straightConnector1">
-            <a:avLst/>
-          </a:prstGeom>
-          <a:noFill/>
-          <a:ln cap="flat" cmpd="sng" w="25400">
-            <a:solidFill>
-              <a:srgbClr val="111111"/>
-            </a:solidFill>
-            <a:prstDash val="solid"/>
-            <a:round/>
-            <a:headEnd len="sm" w="sm" type="none"/>
-            <a:tailEnd len="sm" w="sm" type="none"/>
-          </a:ln>
-        </p:spPr>
-      </p:cxnSp>
-      <p:cxnSp>
-        <p:nvCxnSpPr>
+          <p:cNvSpPr/>
+          <p:nvPr/>
+        </p:nvSpPr>
+        <p:spPr>
+          <a:xfrm>
+            <a:off x="682244" y="274320"/>
+            <a:ext cx="25400" cy="292608"/>
+          </a:xfrm>
+          <a:prstGeom prst="rect">
+            <a:avLst/>
+          </a:prstGeom>
+          <a:solidFill>
+            <a:srgbClr val="111111"/>
+          </a:solidFill>
+          <a:ln>
+            <a:noFill/>
+          </a:ln>
+        </p:spPr>
+        <p:txBody>
+          <a:bodyPr/>
+          <a:lstStyle/>
+          <a:p/>
+        </p:txBody>
+      </p:sp>
+      <p:sp>
+        <p:nvSpPr>
           <p:cNvPr id="264" name="Google Shape;264;p7"/>
-          <p:cNvCxnSpPr/>
-          <p:nvPr/>
-        </p:nvCxnSpPr>
-        <p:spPr>
-          <a:xfrm>
-            <a:off x="694944" y="420624"/>
-            <a:ext cx="146304" cy="1"/>
-          </a:xfrm>
-          <a:prstGeom prst="straightConnector1">
-            <a:avLst/>
-          </a:prstGeom>
-          <a:noFill/>
-          <a:ln cap="flat" cmpd="sng" w="25400">
-            <a:solidFill>
-              <a:srgbClr val="111111"/>
-            </a:solidFill>
-            <a:prstDash val="solid"/>
-            <a:round/>
-            <a:headEnd len="sm" w="sm" type="none"/>
-            <a:tailEnd len="sm" w="sm" type="none"/>
-          </a:ln>
-        </p:spPr>
-      </p:cxnSp>
+          <p:cNvSpPr/>
+          <p:nvPr/>
+        </p:nvSpPr>
+        <p:spPr>
+          <a:xfrm>
+            <a:off x="694944" y="407924"/>
+            <a:ext cx="146304" cy="25400"/>
+          </a:xfrm>
+          <a:prstGeom prst="rect">
+            <a:avLst/>
+          </a:prstGeom>
+          <a:solidFill>
+            <a:srgbClr val="111111"/>
+          </a:solidFill>
+          <a:ln>
+            <a:noFill/>
+          </a:ln>
+        </p:spPr>
+        <p:txBody>
+          <a:bodyPr/>
+          <a:lstStyle/>
+          <a:p/>
+        </p:txBody>
+      </p:sp>
       <p:sp>
         <p:nvSpPr>
           <p:cNvPr id="265" name="Google Shape;265;p7"/>
@@ -15356,32 +15392,33 @@
           </a:p>
         </p:txBody>
       </p:sp>
-      <p:cxnSp>
-        <p:nvCxnSpPr>
+      <p:sp>
+        <p:nvSpPr>
           <p:cNvPr id="268" name="Google Shape;268;p7"/>
-          <p:cNvCxnSpPr/>
-          <p:nvPr/>
-        </p:nvCxnSpPr>
-        <p:spPr>
-          <a:xfrm>
-            <a:off x="548640" y="6455664"/>
-            <a:ext cx="11094415" cy="1"/>
-          </a:xfrm>
-          <a:prstGeom prst="straightConnector1">
-            <a:avLst/>
-          </a:prstGeom>
-          <a:noFill/>
-          <a:ln cap="flat" cmpd="sng" w="28575">
-            <a:solidFill>
-              <a:srgbClr val="111111"/>
-            </a:solidFill>
-            <a:prstDash val="solid"/>
-            <a:round/>
-            <a:headEnd len="sm" w="sm" type="none"/>
-            <a:tailEnd len="sm" w="sm" type="none"/>
-          </a:ln>
-        </p:spPr>
-      </p:cxnSp>
+          <p:cNvSpPr/>
+          <p:nvPr/>
+        </p:nvSpPr>
+        <p:spPr>
+          <a:xfrm>
+            <a:off x="548640" y="6441377"/>
+            <a:ext cx="11094415" cy="28575"/>
+          </a:xfrm>
+          <a:prstGeom prst="rect">
+            <a:avLst/>
+          </a:prstGeom>
+          <a:solidFill>
+            <a:srgbClr val="111111"/>
+          </a:solidFill>
+          <a:ln>
+            <a:noFill/>
+          </a:ln>
+        </p:spPr>
+        <p:txBody>
+          <a:bodyPr/>
+          <a:lstStyle/>
+          <a:p/>
+        </p:txBody>
+      </p:sp>
       <p:sp>
         <p:nvSpPr>
           <p:cNvPr id="269" name="Google Shape;269;p7"/>
@@ -18289,58 +18326,60 @@
           </a:p>
         </p:txBody>
       </p:sp>
-      <p:cxnSp>
-        <p:nvCxnSpPr>
+      <p:sp>
+        <p:nvSpPr>
           <p:cNvPr id="282" name="Google Shape;282;p8"/>
-          <p:cNvCxnSpPr/>
-          <p:nvPr/>
-        </p:nvCxnSpPr>
-        <p:spPr>
-          <a:xfrm>
-            <a:off x="694944" y="274320"/>
-            <a:ext cx="1" cy="292608"/>
-          </a:xfrm>
-          <a:prstGeom prst="straightConnector1">
-            <a:avLst/>
-          </a:prstGeom>
-          <a:noFill/>
-          <a:ln cap="flat" cmpd="sng" w="25400">
-            <a:solidFill>
-              <a:srgbClr val="111111"/>
-            </a:solidFill>
-            <a:prstDash val="solid"/>
-            <a:round/>
-            <a:headEnd len="sm" w="sm" type="none"/>
-            <a:tailEnd len="sm" w="sm" type="none"/>
-          </a:ln>
-        </p:spPr>
-      </p:cxnSp>
-      <p:cxnSp>
-        <p:nvCxnSpPr>
+          <p:cNvSpPr/>
+          <p:nvPr/>
+        </p:nvSpPr>
+        <p:spPr>
+          <a:xfrm>
+            <a:off x="682244" y="274320"/>
+            <a:ext cx="25400" cy="292608"/>
+          </a:xfrm>
+          <a:prstGeom prst="rect">
+            <a:avLst/>
+          </a:prstGeom>
+          <a:solidFill>
+            <a:srgbClr val="111111"/>
+          </a:solidFill>
+          <a:ln>
+            <a:noFill/>
+          </a:ln>
+        </p:spPr>
+        <p:txBody>
+          <a:bodyPr/>
+          <a:lstStyle/>
+          <a:p/>
+        </p:txBody>
+      </p:sp>
+      <p:sp>
+        <p:nvSpPr>
           <p:cNvPr id="283" name="Google Shape;283;p8"/>
-          <p:cNvCxnSpPr/>
-          <p:nvPr/>
-        </p:nvCxnSpPr>
-        <p:spPr>
-          <a:xfrm>
-            <a:off x="694944" y="420624"/>
-            <a:ext cx="146304" cy="1"/>
-          </a:xfrm>
-          <a:prstGeom prst="straightConnector1">
-            <a:avLst/>
-          </a:prstGeom>
-          <a:noFill/>
-          <a:ln cap="flat" cmpd="sng" w="25400">
-            <a:solidFill>
-              <a:srgbClr val="111111"/>
-            </a:solidFill>
-            <a:prstDash val="solid"/>
-            <a:round/>
-            <a:headEnd len="sm" w="sm" type="none"/>
-            <a:tailEnd len="sm" w="sm" type="none"/>
-          </a:ln>
-        </p:spPr>
-      </p:cxnSp>
+          <p:cNvSpPr/>
+          <p:nvPr/>
+        </p:nvSpPr>
+        <p:spPr>
+          <a:xfrm>
+            <a:off x="694944" y="407924"/>
+            <a:ext cx="146304" cy="25400"/>
+          </a:xfrm>
+          <a:prstGeom prst="rect">
+            <a:avLst/>
+          </a:prstGeom>
+          <a:solidFill>
+            <a:srgbClr val="111111"/>
+          </a:solidFill>
+          <a:ln>
+            <a:noFill/>
+          </a:ln>
+        </p:spPr>
+        <p:txBody>
+          <a:bodyPr/>
+          <a:lstStyle/>
+          <a:p/>
+        </p:txBody>
+      </p:sp>
       <p:sp>
         <p:nvSpPr>
           <p:cNvPr id="284" name="Google Shape;284;p8"/>
@@ -18521,32 +18560,33 @@
           </a:p>
         </p:txBody>
       </p:sp>
-      <p:cxnSp>
-        <p:nvCxnSpPr>
+      <p:sp>
+        <p:nvSpPr>
           <p:cNvPr id="287" name="Google Shape;287;p8"/>
-          <p:cNvCxnSpPr/>
-          <p:nvPr/>
-        </p:nvCxnSpPr>
-        <p:spPr>
-          <a:xfrm>
-            <a:off x="548640" y="6455664"/>
-            <a:ext cx="11094415" cy="1"/>
-          </a:xfrm>
-          <a:prstGeom prst="straightConnector1">
-            <a:avLst/>
-          </a:prstGeom>
-          <a:noFill/>
-          <a:ln cap="flat" cmpd="sng" w="28575">
-            <a:solidFill>
-              <a:srgbClr val="111111"/>
-            </a:solidFill>
-            <a:prstDash val="solid"/>
-            <a:round/>
-            <a:headEnd len="sm" w="sm" type="none"/>
-            <a:tailEnd len="sm" w="sm" type="none"/>
-          </a:ln>
-        </p:spPr>
-      </p:cxnSp>
+          <p:cNvSpPr/>
+          <p:nvPr/>
+        </p:nvSpPr>
+        <p:spPr>
+          <a:xfrm>
+            <a:off x="548640" y="6441377"/>
+            <a:ext cx="11094415" cy="28575"/>
+          </a:xfrm>
+          <a:prstGeom prst="rect">
+            <a:avLst/>
+          </a:prstGeom>
+          <a:solidFill>
+            <a:srgbClr val="111111"/>
+          </a:solidFill>
+          <a:ln>
+            <a:noFill/>
+          </a:ln>
+        </p:spPr>
+        <p:txBody>
+          <a:bodyPr/>
+          <a:lstStyle/>
+          <a:p/>
+        </p:txBody>
+      </p:sp>
       <p:sp>
         <p:nvSpPr>
           <p:cNvPr id="288" name="Google Shape;288;p8"/>
@@ -18900,58 +18940,60 @@
           </a:p>
         </p:txBody>
       </p:sp>
-      <p:cxnSp>
-        <p:nvCxnSpPr>
+      <p:sp>
+        <p:nvSpPr>
           <p:cNvPr id="294" name="Google Shape;294;p8"/>
-          <p:cNvCxnSpPr/>
-          <p:nvPr/>
-        </p:nvCxnSpPr>
-        <p:spPr>
-          <a:xfrm>
-            <a:off x="1060704" y="5532120"/>
-            <a:ext cx="1" cy="384048"/>
-          </a:xfrm>
-          <a:prstGeom prst="straightConnector1">
-            <a:avLst/>
-          </a:prstGeom>
-          <a:noFill/>
-          <a:ln cap="flat" cmpd="sng" w="25400">
-            <a:solidFill>
-              <a:srgbClr val="111111"/>
-            </a:solidFill>
-            <a:prstDash val="solid"/>
-            <a:round/>
-            <a:headEnd len="sm" w="sm" type="none"/>
-            <a:tailEnd len="sm" w="sm" type="none"/>
-          </a:ln>
-        </p:spPr>
-      </p:cxnSp>
-      <p:cxnSp>
-        <p:nvCxnSpPr>
+          <p:cNvSpPr/>
+          <p:nvPr/>
+        </p:nvSpPr>
+        <p:spPr>
+          <a:xfrm>
+            <a:off x="1048004" y="5532120"/>
+            <a:ext cx="25400" cy="384048"/>
+          </a:xfrm>
+          <a:prstGeom prst="rect">
+            <a:avLst/>
+          </a:prstGeom>
+          <a:solidFill>
+            <a:srgbClr val="111111"/>
+          </a:solidFill>
+          <a:ln>
+            <a:noFill/>
+          </a:ln>
+        </p:spPr>
+        <p:txBody>
+          <a:bodyPr/>
+          <a:lstStyle/>
+          <a:p/>
+        </p:txBody>
+      </p:sp>
+      <p:sp>
+        <p:nvSpPr>
           <p:cNvPr id="295" name="Google Shape;295;p8"/>
-          <p:cNvCxnSpPr/>
-          <p:nvPr/>
-        </p:nvCxnSpPr>
-        <p:spPr>
-          <a:xfrm>
-            <a:off x="1060704" y="5724144"/>
-            <a:ext cx="192024" cy="1"/>
-          </a:xfrm>
-          <a:prstGeom prst="straightConnector1">
-            <a:avLst/>
-          </a:prstGeom>
-          <a:noFill/>
-          <a:ln cap="flat" cmpd="sng" w="25400">
-            <a:solidFill>
-              <a:srgbClr val="111111"/>
-            </a:solidFill>
-            <a:prstDash val="solid"/>
-            <a:round/>
-            <a:headEnd len="sm" w="sm" type="none"/>
-            <a:tailEnd len="sm" w="sm" type="none"/>
-          </a:ln>
-        </p:spPr>
-      </p:cxnSp>
+          <p:cNvSpPr/>
+          <p:nvPr/>
+        </p:nvSpPr>
+        <p:spPr>
+          <a:xfrm>
+            <a:off x="1060704" y="5711444"/>
+            <a:ext cx="192024" cy="25400"/>
+          </a:xfrm>
+          <a:prstGeom prst="rect">
+            <a:avLst/>
+          </a:prstGeom>
+          <a:solidFill>
+            <a:srgbClr val="111111"/>
+          </a:solidFill>
+          <a:ln>
+            <a:noFill/>
+          </a:ln>
+        </p:spPr>
+        <p:txBody>
+          <a:bodyPr/>
+          <a:lstStyle/>
+          <a:p/>
+        </p:txBody>
+      </p:sp>
       <p:pic>
         <p:nvPicPr>
           <p:cNvPr id="296" name="Picture 295" descr="causal-graph.png"/>
@@ -19055,58 +19097,60 @@
           </a:p>
         </p:txBody>
       </p:sp>
-      <p:cxnSp>
-        <p:nvCxnSpPr>
+      <p:sp>
+        <p:nvSpPr>
           <p:cNvPr id="304" name="Google Shape;304;p9"/>
-          <p:cNvCxnSpPr/>
-          <p:nvPr/>
-        </p:nvCxnSpPr>
-        <p:spPr>
-          <a:xfrm>
-            <a:off x="694944" y="274320"/>
-            <a:ext cx="1" cy="292608"/>
-          </a:xfrm>
-          <a:prstGeom prst="straightConnector1">
-            <a:avLst/>
-          </a:prstGeom>
-          <a:noFill/>
-          <a:ln cap="flat" cmpd="sng" w="25400">
-            <a:solidFill>
-              <a:srgbClr val="111111"/>
-            </a:solidFill>
-            <a:prstDash val="solid"/>
-            <a:round/>
-            <a:headEnd len="sm" w="sm" type="none"/>
-            <a:tailEnd len="sm" w="sm" type="none"/>
-          </a:ln>
-        </p:spPr>
-      </p:cxnSp>
-      <p:cxnSp>
-        <p:nvCxnSpPr>
+          <p:cNvSpPr/>
+          <p:nvPr/>
+        </p:nvSpPr>
+        <p:spPr>
+          <a:xfrm>
+            <a:off x="682244" y="274320"/>
+            <a:ext cx="25400" cy="292608"/>
+          </a:xfrm>
+          <a:prstGeom prst="rect">
+            <a:avLst/>
+          </a:prstGeom>
+          <a:solidFill>
+            <a:srgbClr val="111111"/>
+          </a:solidFill>
+          <a:ln>
+            <a:noFill/>
+          </a:ln>
+        </p:spPr>
+        <p:txBody>
+          <a:bodyPr/>
+          <a:lstStyle/>
+          <a:p/>
+        </p:txBody>
+      </p:sp>
+      <p:sp>
+        <p:nvSpPr>
           <p:cNvPr id="305" name="Google Shape;305;p9"/>
-          <p:cNvCxnSpPr/>
-          <p:nvPr/>
-        </p:nvCxnSpPr>
-        <p:spPr>
-          <a:xfrm>
-            <a:off x="694944" y="420624"/>
-            <a:ext cx="146304" cy="1"/>
-          </a:xfrm>
-          <a:prstGeom prst="straightConnector1">
-            <a:avLst/>
-          </a:prstGeom>
-          <a:noFill/>
-          <a:ln cap="flat" cmpd="sng" w="25400">
-            <a:solidFill>
-              <a:srgbClr val="111111"/>
-            </a:solidFill>
-            <a:prstDash val="solid"/>
-            <a:round/>
-            <a:headEnd len="sm" w="sm" type="none"/>
-            <a:tailEnd len="sm" w="sm" type="none"/>
-          </a:ln>
-        </p:spPr>
-      </p:cxnSp>
+          <p:cNvSpPr/>
+          <p:nvPr/>
+        </p:nvSpPr>
+        <p:spPr>
+          <a:xfrm>
+            <a:off x="694944" y="407924"/>
+            <a:ext cx="146304" cy="25400"/>
+          </a:xfrm>
+          <a:prstGeom prst="rect">
+            <a:avLst/>
+          </a:prstGeom>
+          <a:solidFill>
+            <a:srgbClr val="111111"/>
+          </a:solidFill>
+          <a:ln>
+            <a:noFill/>
+          </a:ln>
+        </p:spPr>
+        <p:txBody>
+          <a:bodyPr/>
+          <a:lstStyle/>
+          <a:p/>
+        </p:txBody>
+      </p:sp>
       <p:sp>
         <p:nvSpPr>
           <p:cNvPr id="306" name="Google Shape;306;p9"/>
@@ -19287,32 +19331,33 @@
           </a:p>
         </p:txBody>
       </p:sp>
-      <p:cxnSp>
-        <p:nvCxnSpPr>
+      <p:sp>
+        <p:nvSpPr>
           <p:cNvPr id="309" name="Google Shape;309;p9"/>
-          <p:cNvCxnSpPr/>
-          <p:nvPr/>
-        </p:nvCxnSpPr>
-        <p:spPr>
-          <a:xfrm>
-            <a:off x="548640" y="6455664"/>
-            <a:ext cx="11094415" cy="1"/>
-          </a:xfrm>
-          <a:prstGeom prst="straightConnector1">
-            <a:avLst/>
-          </a:prstGeom>
-          <a:noFill/>
-          <a:ln cap="flat" cmpd="sng" w="28575">
-            <a:solidFill>
-              <a:srgbClr val="111111"/>
-            </a:solidFill>
-            <a:prstDash val="solid"/>
-            <a:round/>
-            <a:headEnd len="sm" w="sm" type="none"/>
-            <a:tailEnd len="sm" w="sm" type="none"/>
-          </a:ln>
-        </p:spPr>
-      </p:cxnSp>
+          <p:cNvSpPr/>
+          <p:nvPr/>
+        </p:nvSpPr>
+        <p:spPr>
+          <a:xfrm>
+            <a:off x="548640" y="6441377"/>
+            <a:ext cx="11094415" cy="28575"/>
+          </a:xfrm>
+          <a:prstGeom prst="rect">
+            <a:avLst/>
+          </a:prstGeom>
+          <a:solidFill>
+            <a:srgbClr val="111111"/>
+          </a:solidFill>
+          <a:ln>
+            <a:noFill/>
+          </a:ln>
+        </p:spPr>
+        <p:txBody>
+          <a:bodyPr/>
+          <a:lstStyle/>
+          <a:p/>
+        </p:txBody>
+      </p:sp>
       <p:sp>
         <p:nvSpPr>
           <p:cNvPr id="310" name="Google Shape;310;p9"/>
@@ -19742,7 +19787,7 @@
         </p:nvGraphicFramePr>
         <p:xfrm>
           <a:off x="548640" y="2596896"/>
-          <a:ext cx="3000000" cy="2048275"/>
+          <a:ext cx="3000000" cy="3000000"/>
         </p:xfrm>
         <a:graphic>
           <a:graphicData uri="http://schemas.openxmlformats.org/drawingml/2006/table">
@@ -20841,58 +20886,60 @@
           </a:p>
         </p:txBody>
       </p:sp>
-      <p:cxnSp>
-        <p:nvCxnSpPr>
+      <p:sp>
+        <p:nvSpPr>
           <p:cNvPr id="320" name="Google Shape;320;p9"/>
-          <p:cNvCxnSpPr/>
-          <p:nvPr/>
-        </p:nvCxnSpPr>
-        <p:spPr>
-          <a:xfrm>
-            <a:off x="11155680" y="5870448"/>
-            <a:ext cx="1" cy="365760"/>
-          </a:xfrm>
-          <a:prstGeom prst="straightConnector1">
-            <a:avLst/>
-          </a:prstGeom>
-          <a:noFill/>
-          <a:ln cap="flat" cmpd="sng" w="25400">
-            <a:solidFill>
-              <a:srgbClr val="111111"/>
-            </a:solidFill>
-            <a:prstDash val="solid"/>
-            <a:round/>
-            <a:headEnd len="sm" w="sm" type="none"/>
-            <a:tailEnd len="sm" w="sm" type="none"/>
-          </a:ln>
-        </p:spPr>
-      </p:cxnSp>
-      <p:cxnSp>
-        <p:nvCxnSpPr>
+          <p:cNvSpPr/>
+          <p:nvPr/>
+        </p:nvSpPr>
+        <p:spPr>
+          <a:xfrm>
+            <a:off x="11142980" y="5870448"/>
+            <a:ext cx="25400" cy="365760"/>
+          </a:xfrm>
+          <a:prstGeom prst="rect">
+            <a:avLst/>
+          </a:prstGeom>
+          <a:solidFill>
+            <a:srgbClr val="111111"/>
+          </a:solidFill>
+          <a:ln>
+            <a:noFill/>
+          </a:ln>
+        </p:spPr>
+        <p:txBody>
+          <a:bodyPr/>
+          <a:lstStyle/>
+          <a:p/>
+        </p:txBody>
+      </p:sp>
+      <p:sp>
+        <p:nvSpPr>
           <p:cNvPr id="321" name="Google Shape;321;p9"/>
-          <p:cNvCxnSpPr/>
-          <p:nvPr/>
-        </p:nvCxnSpPr>
-        <p:spPr>
-          <a:xfrm>
-            <a:off x="11155680" y="6053328"/>
-            <a:ext cx="182880" cy="1"/>
-          </a:xfrm>
-          <a:prstGeom prst="straightConnector1">
-            <a:avLst/>
-          </a:prstGeom>
-          <a:noFill/>
-          <a:ln cap="flat" cmpd="sng" w="25400">
-            <a:solidFill>
-              <a:srgbClr val="111111"/>
-            </a:solidFill>
-            <a:prstDash val="solid"/>
-            <a:round/>
-            <a:headEnd len="sm" w="sm" type="none"/>
-            <a:tailEnd len="sm" w="sm" type="none"/>
-          </a:ln>
-        </p:spPr>
-      </p:cxnSp>
+          <p:cNvSpPr/>
+          <p:nvPr/>
+        </p:nvSpPr>
+        <p:spPr>
+          <a:xfrm>
+            <a:off x="11155680" y="6040628"/>
+            <a:ext cx="182880" cy="25400"/>
+          </a:xfrm>
+          <a:prstGeom prst="rect">
+            <a:avLst/>
+          </a:prstGeom>
+          <a:solidFill>
+            <a:srgbClr val="111111"/>
+          </a:solidFill>
+          <a:ln>
+            <a:noFill/>
+          </a:ln>
+        </p:spPr>
+        <p:txBody>
+          <a:bodyPr/>
+          <a:lstStyle/>
+          <a:p/>
+        </p:txBody>
+      </p:sp>
     </p:spTree>
   </p:cSld>
   <p:clrMapOvr>

</xml_diff>